<commit_message>
Section2b: match HTML formatting — study cards (left cyan accent + PRISM left-bar), ICH stacked statlines (amber/warn/warn/cyan) + GIF placeholder, EMBED cyan-keyword chips + V2 label + MAP placeholder, density (text left/stats right + divider), CCC 2-col table w/ amber highlight + left-bar + placeholder box
</commit_message>
<xml_diff>
--- a/keynote-iwbi-2026/pptx/sections/IWBI2026_Trivedi_02b_EraII_2026.pptx
+++ b/keynote-iwbi-2026/pptx/sections/IWBI2026_Trivedi_02b_EraII_2026.pptx
@@ -5304,8 +5304,101 @@
         </p:nvSpPr>
         <p:spPr>
           <a:xfrm>
-            <a:off x="777240" y="1371600"/>
-            <a:ext cx="10424160" cy="2194560"/>
+            <a:off x="777240" y="1828800"/>
+            <a:ext cx="6126480" cy="2926080"/>
+          </a:xfrm>
+          <a:prstGeom prst="rect">
+            <a:avLst/>
+          </a:prstGeom>
+          <a:noFill/>
+        </p:spPr>
+        <p:txBody>
+          <a:bodyPr wrap="square" anchor="t" lIns="0" rIns="0" tIns="0" bIns="0">
+            <a:spAutoFit/>
+          </a:bodyPr>
+          <a:lstStyle/>
+          <a:p>
+            <a:pPr algn="l">
+              <a:lnSpc>
+                <a:spcPct val="132000"/>
+              </a:lnSpc>
+            </a:pPr>
+            <a:r>
+              <a:rPr sz="2400" b="0" i="0">
+                <a:solidFill>
+                  <a:srgbClr val="9DA9B5"/>
+                </a:solidFill>
+                <a:latin typeface="Arial"/>
+              </a:rPr>
+              <a:t>For 40 years, the only risk signal we could read off the image was </a:t>
+            </a:r>
+            <a:r>
+              <a:rPr sz="2400" b="0" i="0">
+                <a:solidFill>
+                  <a:srgbClr val="E7AC51"/>
+                </a:solidFill>
+                <a:latin typeface="Arial"/>
+              </a:rPr>
+              <a:t>density</a:t>
+            </a:r>
+            <a:r>
+              <a:rPr sz="2400" b="0" i="0">
+                <a:solidFill>
+                  <a:srgbClr val="9DA9B5"/>
+                </a:solidFill>
+                <a:latin typeface="Arial"/>
+              </a:rPr>
+              <a:t>. The clinical models layered on top — </a:t>
+            </a:r>
+            <a:r>
+              <a:rPr sz="2400" b="0" i="0">
+                <a:solidFill>
+                  <a:srgbClr val="E7AC51"/>
+                </a:solidFill>
+                <a:latin typeface="Arial"/>
+              </a:rPr>
+              <a:t>Gail</a:t>
+            </a:r>
+            <a:r>
+              <a:rPr sz="2400" b="0" i="0">
+                <a:solidFill>
+                  <a:srgbClr val="9DA9B5"/>
+                </a:solidFill>
+                <a:latin typeface="Arial"/>
+              </a:rPr>
+              <a:t> and </a:t>
+            </a:r>
+            <a:r>
+              <a:rPr sz="2400" b="0" i="0">
+                <a:solidFill>
+                  <a:srgbClr val="E7AC51"/>
+                </a:solidFill>
+                <a:latin typeface="Arial"/>
+              </a:rPr>
+              <a:t>Tyrer-Cuzick</a:t>
+            </a:r>
+            <a:r>
+              <a:rPr sz="2400" b="0" i="0">
+                <a:solidFill>
+                  <a:srgbClr val="9DA9B5"/>
+                </a:solidFill>
+                <a:latin typeface="Arial"/>
+              </a:rPr>
+              <a:t> — were hardly better than a coin flip.</a:t>
+            </a:r>
+          </a:p>
+        </p:txBody>
+      </p:sp>
+      <p:sp>
+        <p:nvSpPr>
+          <p:cNvPr id="6" name="TextBox 5"/>
+          <p:cNvSpPr txBox="1"/>
+          <p:nvPr/>
+        </p:nvSpPr>
+        <p:spPr>
+          <a:xfrm>
+            <a:off x="777240" y="5120640"/>
+            <a:ext cx="6126480" cy="457200"/>
           </a:xfrm>
           <a:prstGeom prst="rect">
             <a:avLst/>
@@ -5324,81 +5417,71 @@
               </a:lnSpc>
             </a:pPr>
             <a:r>
-              <a:rPr sz="2200" b="0" i="0">
-                <a:solidFill>
-                  <a:srgbClr val="9DA9B5"/>
-                </a:solidFill>
-                <a:latin typeface="Arial"/>
-              </a:rPr>
-              <a:t>For 40 years, the only risk signal we could read off the image was </a:t>
-            </a:r>
-            <a:r>
-              <a:rPr sz="2200" b="1" i="0">
-                <a:solidFill>
-                  <a:srgbClr val="ECEFF3"/>
-                </a:solidFill>
-                <a:latin typeface="Arial"/>
-              </a:rPr>
-              <a:t>density.</a:t>
-            </a:r>
-            <a:r>
-              <a:rPr sz="2200" b="0" i="0">
-                <a:solidFill>
-                  <a:srgbClr val="9DA9B5"/>
-                </a:solidFill>
-                <a:latin typeface="Arial"/>
-              </a:rPr>
-              <a:t> The clinical models layered on top — </a:t>
-            </a:r>
-            <a:r>
-              <a:rPr sz="2200" b="1" i="0">
-                <a:solidFill>
-                  <a:srgbClr val="ECEFF3"/>
-                </a:solidFill>
-                <a:latin typeface="Arial"/>
-              </a:rPr>
-              <a:t>Gail</a:t>
-            </a:r>
-            <a:r>
-              <a:rPr sz="2200" b="0" i="0">
-                <a:solidFill>
-                  <a:srgbClr val="9DA9B5"/>
-                </a:solidFill>
-                <a:latin typeface="Arial"/>
-              </a:rPr>
-              <a:t> and </a:t>
-            </a:r>
-            <a:r>
-              <a:rPr sz="2200" b="1" i="0">
-                <a:solidFill>
-                  <a:srgbClr val="ECEFF3"/>
-                </a:solidFill>
-                <a:latin typeface="Arial"/>
-              </a:rPr>
-              <a:t>Tyrer-Cuzick</a:t>
-            </a:r>
-            <a:r>
-              <a:rPr sz="2200" b="0" i="0">
-                <a:solidFill>
-                  <a:srgbClr val="9DA9B5"/>
-                </a:solidFill>
-                <a:latin typeface="Arial"/>
-              </a:rPr>
-              <a:t> — were hardly better than a coin flip.</a:t>
-            </a:r>
-          </a:p>
-        </p:txBody>
-      </p:sp>
-      <p:sp>
-        <p:nvSpPr>
-          <p:cNvPr id="6" name="TextBox 5"/>
+              <a:rPr sz="950" b="0" i="0">
+                <a:solidFill>
+                  <a:srgbClr val="5C6975"/>
+                </a:solidFill>
+                <a:latin typeface="Consolas"/>
+              </a:rPr>
+              <a:t>Gail · Tyrer-Cuzick · BCSC — questionnaire + density models</a:t>
+            </a:r>
+          </a:p>
+        </p:txBody>
+      </p:sp>
+      <p:sp>
+        <p:nvSpPr>
+          <p:cNvPr id="7" name="Rectangle 6"/>
+          <p:cNvSpPr/>
+          <p:nvPr/>
+        </p:nvSpPr>
+        <p:spPr>
+          <a:xfrm>
+            <a:off x="7315200" y="2011680"/>
+            <a:ext cx="12700" cy="2194560"/>
+          </a:xfrm>
+          <a:prstGeom prst="rect">
+            <a:avLst/>
+          </a:prstGeom>
+          <a:solidFill>
+            <a:srgbClr val="2A333D"/>
+          </a:solidFill>
+          <a:ln>
+            <a:noFill/>
+          </a:ln>
+          <a:effectLst/>
+        </p:spPr>
+        <p:style>
+          <a:lnRef idx="1">
+            <a:schemeClr val="accent1"/>
+          </a:lnRef>
+          <a:fillRef idx="3">
+            <a:schemeClr val="accent1"/>
+          </a:fillRef>
+          <a:effectRef idx="2">
+            <a:schemeClr val="accent1"/>
+          </a:effectRef>
+          <a:fontRef idx="minor">
+            <a:schemeClr val="lt1"/>
+          </a:fontRef>
+        </p:style>
+        <p:txBody>
+          <a:bodyPr rtlCol="0" anchor="ctr"/>
+          <a:lstStyle/>
+          <a:p>
+            <a:pPr algn="ctr"/>
+          </a:p>
+        </p:txBody>
+      </p:sp>
+      <p:sp>
+        <p:nvSpPr>
+          <p:cNvPr id="8" name="TextBox 7"/>
           <p:cNvSpPr txBox="1"/>
           <p:nvPr/>
         </p:nvSpPr>
         <p:spPr>
           <a:xfrm>
-            <a:off x="777240" y="3749039"/>
-            <a:ext cx="4572000" cy="502920"/>
+            <a:off x="7680960" y="2148840"/>
+            <a:ext cx="4206240" cy="502920"/>
           </a:xfrm>
           <a:prstGeom prst="rect">
             <a:avLst/>
@@ -5417,9 +5500,9 @@
               </a:lnSpc>
             </a:pPr>
             <a:r>
-              <a:rPr sz="4400" b="1" i="0">
-                <a:solidFill>
-                  <a:srgbClr val="E7AC51"/>
+              <a:rPr sz="2200" b="1" i="0">
+                <a:solidFill>
+                  <a:srgbClr val="ECEFF3"/>
                 </a:solidFill>
                 <a:latin typeface="Arial"/>
               </a:rPr>
@@ -5430,14 +5513,14 @@
       </p:sp>
       <p:sp>
         <p:nvSpPr>
-          <p:cNvPr id="7" name="TextBox 6"/>
+          <p:cNvPr id="9" name="TextBox 8"/>
           <p:cNvSpPr txBox="1"/>
           <p:nvPr/>
         </p:nvSpPr>
         <p:spPr>
           <a:xfrm>
-            <a:off x="777240" y="4242816"/>
-            <a:ext cx="4572000" cy="548640"/>
+            <a:off x="7680960" y="2441448"/>
+            <a:ext cx="4206240" cy="548640"/>
           </a:xfrm>
           <a:prstGeom prst="rect">
             <a:avLst/>
@@ -5469,14 +5552,14 @@
       </p:sp>
       <p:sp>
         <p:nvSpPr>
-          <p:cNvPr id="8" name="TextBox 7"/>
+          <p:cNvPr id="10" name="TextBox 9"/>
           <p:cNvSpPr txBox="1"/>
           <p:nvPr/>
         </p:nvSpPr>
         <p:spPr>
           <a:xfrm>
-            <a:off x="5943600" y="3749039"/>
-            <a:ext cx="5029200" cy="502920"/>
+            <a:off x="7680960" y="2971800"/>
+            <a:ext cx="4206240" cy="502920"/>
           </a:xfrm>
           <a:prstGeom prst="rect">
             <a:avLst/>
@@ -5495,9 +5578,9 @@
               </a:lnSpc>
             </a:pPr>
             <a:r>
-              <a:rPr sz="4400" b="1" i="0">
-                <a:solidFill>
-                  <a:srgbClr val="E7AC51"/>
+              <a:rPr sz="2200" b="1" i="0">
+                <a:solidFill>
+                  <a:srgbClr val="ECEFF3"/>
                 </a:solidFill>
                 <a:latin typeface="Arial"/>
               </a:rPr>
@@ -5508,14 +5591,14 @@
       </p:sp>
       <p:sp>
         <p:nvSpPr>
-          <p:cNvPr id="9" name="TextBox 8"/>
+          <p:cNvPr id="11" name="TextBox 10"/>
           <p:cNvSpPr txBox="1"/>
           <p:nvPr/>
         </p:nvSpPr>
         <p:spPr>
           <a:xfrm>
-            <a:off x="5943600" y="4242816"/>
-            <a:ext cx="5029200" cy="548640"/>
+            <a:off x="7680960" y="3264408"/>
+            <a:ext cx="4206240" cy="548640"/>
           </a:xfrm>
           <a:prstGeom prst="rect">
             <a:avLst/>
@@ -5547,14 +5630,14 @@
       </p:sp>
       <p:sp>
         <p:nvSpPr>
-          <p:cNvPr id="10" name="TextBox 9"/>
+          <p:cNvPr id="12" name="TextBox 11"/>
           <p:cNvSpPr txBox="1"/>
           <p:nvPr/>
         </p:nvSpPr>
         <p:spPr>
           <a:xfrm>
-            <a:off x="777240" y="5303520"/>
-            <a:ext cx="10424160" cy="548640"/>
+            <a:off x="7680960" y="3886200"/>
+            <a:ext cx="4206240" cy="822960"/>
           </a:xfrm>
           <a:prstGeom prst="rect">
             <a:avLst/>
@@ -5569,11 +5652,11 @@
           <a:p>
             <a:pPr algn="l">
               <a:lnSpc>
-                <a:spcPct val="140000"/>
+                <a:spcPct val="135000"/>
               </a:lnSpc>
             </a:pPr>
             <a:r>
-              <a:rPr sz="1500" b="1" i="0">
+              <a:rPr sz="1300" b="0" i="0">
                 <a:solidFill>
                   <a:srgbClr val="ECEFF3"/>
                 </a:solidFill>
@@ -5582,7 +5665,7 @@
               <a:t>Coin flip is 0.50. </a:t>
             </a:r>
             <a:r>
-              <a:rPr sz="1500" b="0" i="0">
+              <a:rPr sz="1300" b="0" i="0">
                 <a:solidFill>
                   <a:srgbClr val="9DA9B5"/>
                 </a:solidFill>
@@ -8350,7 +8433,7 @@
         <p:spPr>
           <a:xfrm>
             <a:off x="777240" y="1005840"/>
-            <a:ext cx="8229600" cy="1097280"/>
+            <a:ext cx="5852160" cy="1097280"/>
           </a:xfrm>
           <a:prstGeom prst="rect">
             <a:avLst/>
@@ -8397,8 +8480,8 @@
         </p:nvSpPr>
         <p:spPr>
           <a:xfrm>
-            <a:off x="777240" y="2194560"/>
-            <a:ext cx="10424160" cy="1097280"/>
+            <a:off x="777240" y="2148840"/>
+            <a:ext cx="5669280" cy="1280160"/>
           </a:xfrm>
           <a:prstGeom prst="rect">
             <a:avLst/>
@@ -8417,7 +8500,7 @@
               </a:lnSpc>
             </a:pPr>
             <a:r>
-              <a:rPr sz="1500" b="0" i="0">
+              <a:rPr sz="1400" b="0" i="0">
                 <a:solidFill>
                   <a:srgbClr val="9DA9B5"/>
                 </a:solidFill>
@@ -8426,7 +8509,7 @@
               <a:t>A </a:t>
             </a:r>
             <a:r>
-              <a:rPr sz="1500" b="1" i="0">
+              <a:rPr sz="1400" b="1" i="0">
                 <a:solidFill>
                   <a:srgbClr val="ECEFF3"/>
                 </a:solidFill>
@@ -8435,7 +8518,7 @@
               <a:t>non-vascular</a:t>
             </a:r>
             <a:r>
-              <a:rPr sz="1500" b="0" i="0">
+              <a:rPr sz="1400" b="0" i="0">
                 <a:solidFill>
                   <a:srgbClr val="9DA9B5"/>
                 </a:solidFill>
@@ -8444,7 +8527,7 @@
               <a:t> marker — calcification in the costal cartilage on chest CT (</a:t>
             </a:r>
             <a:r>
-              <a:rPr sz="1500" b="1" i="0">
+              <a:rPr sz="1400" b="1" i="0">
                 <a:solidFill>
                   <a:srgbClr val="ECEFF3"/>
                 </a:solidFill>
@@ -8453,266 +8536,61 @@
               <a:t>n=1,311</a:t>
             </a:r>
             <a:r>
-              <a:rPr sz="1500" b="0" i="0">
+              <a:rPr sz="1400" b="0" i="0">
                 <a:solidFill>
                   <a:srgbClr val="9DA9B5"/>
                 </a:solidFill>
                 <a:latin typeface="Arial"/>
               </a:rPr>
-              <a:t>). Correlated with BAC (ρ=0.089, p=0.001). </a:t>
-            </a:r>
-            <a:r>
-              <a:rPr sz="1500" b="1" i="0">
-                <a:solidFill>
-                  <a:srgbClr val="ECEFF3"/>
-                </a:solidFill>
-                <a:latin typeface="Arial"/>
-              </a:rPr>
-              <a:t>Vascular + valvular + skeletal — one free mammographic finding.</a:t>
-            </a:r>
-          </a:p>
-        </p:txBody>
-      </p:sp>
-      <p:graphicFrame>
-        <p:nvGraphicFramePr>
-          <p:cNvPr id="7" name="Table 6"/>
-          <p:cNvGraphicFramePr>
-            <a:graphicFrameLocks noGrp="1"/>
-          </p:cNvGraphicFramePr>
-          <p:nvPr/>
-        </p:nvGraphicFramePr>
-        <p:xfrm>
-          <a:off x="777240" y="3749039"/>
-          <a:ext cx="7772400" cy="987552"/>
-        </p:xfrm>
-        <a:graphic>
-          <a:graphicData uri="http://schemas.openxmlformats.org/drawingml/2006/table">
-            <a:tbl>
-              <a:tblPr firstRow="1" bandRow="1">
-                <a:tableStyleId>{5C22544A-7EE6-4342-B048-85BDC9FD1C3A}</a:tableStyleId>
-              </a:tblPr>
-              <a:tblGrid>
-                <a:gridCol w="3840480"/>
-                <a:gridCol w="1965960"/>
-                <a:gridCol w="1965960"/>
-              </a:tblGrid>
-              <a:tr h="329184">
-                <a:tc>
-                  <a:txBody>
-                    <a:bodyPr/>
-                    <a:lstStyle/>
-                    <a:p>
-                      <a:pPr algn="l"/>
-                      <a:r>
-                        <a:rPr sz="1300" b="1">
-                          <a:solidFill>
-                            <a:srgbClr val="E7AC51"/>
-                          </a:solidFill>
-                          <a:latin typeface="Arial"/>
-                        </a:rPr>
-                        <a:t>High BAC vs zero (ΔCCC)</a:t>
-                      </a:r>
-                    </a:p>
-                  </a:txBody>
-                  <a:tcPr anchor="ctr" marL="73152" marR="73152" marT="25400" marB="25400">
-                    <a:solidFill>
-                      <a:srgbClr val="0F141A"/>
-                    </a:solidFill>
-                  </a:tcPr>
-                </a:tc>
-                <a:tc>
-                  <a:txBody>
-                    <a:bodyPr/>
-                    <a:lstStyle/>
-                    <a:p>
-                      <a:pPr algn="ctr"/>
-                      <a:r>
-                        <a:rPr sz="1300" b="1">
-                          <a:solidFill>
-                            <a:srgbClr val="E7AC51"/>
-                          </a:solidFill>
-                          <a:latin typeface="Arial"/>
-                        </a:rPr>
-                        <a:t>adj. p</a:t>
-                      </a:r>
-                    </a:p>
-                  </a:txBody>
-                  <a:tcPr anchor="ctr" marL="73152" marR="73152" marT="25400" marB="25400">
-                    <a:solidFill>
-                      <a:srgbClr val="0F141A"/>
-                    </a:solidFill>
-                  </a:tcPr>
-                </a:tc>
-                <a:tc>
-                  <a:txBody>
-                    <a:bodyPr/>
-                    <a:lstStyle/>
-                    <a:p>
-                      <a:pPr algn="ctr"/>
-                      <a:r>
-                        <a:rPr sz="1300" b="1">
-                          <a:solidFill>
-                            <a:srgbClr val="E7AC51"/>
-                          </a:solidFill>
-                          <a:latin typeface="Arial"/>
-                        </a:rPr>
-                        <a:t>Δ</a:t>
-                      </a:r>
-                    </a:p>
-                  </a:txBody>
-                  <a:tcPr anchor="ctr" marL="73152" marR="73152" marT="25400" marB="25400">
-                    <a:solidFill>
-                      <a:srgbClr val="0F141A"/>
-                    </a:solidFill>
-                  </a:tcPr>
-                </a:tc>
-              </a:tr>
-              <a:tr h="329184">
-                <a:tc>
-                  <a:txBody>
-                    <a:bodyPr/>
-                    <a:lstStyle/>
-                    <a:p>
-                      <a:pPr algn="l"/>
-                      <a:r>
-                        <a:rPr sz="1300" b="0">
-                          <a:solidFill>
-                            <a:srgbClr val="ECEFF3"/>
-                          </a:solidFill>
-                          <a:latin typeface="Arial"/>
-                        </a:rPr>
-                        <a:t>Median (q0.50)</a:t>
-                      </a:r>
-                    </a:p>
-                  </a:txBody>
-                  <a:tcPr anchor="ctr" marL="73152" marR="73152" marT="25400" marB="25400">
-                    <a:solidFill>
-                      <a:srgbClr val="0F141A"/>
-                    </a:solidFill>
-                  </a:tcPr>
-                </a:tc>
-                <a:tc>
-                  <a:txBody>
-                    <a:bodyPr/>
-                    <a:lstStyle/>
-                    <a:p>
-                      <a:pPr algn="ctr"/>
-                      <a:r>
-                        <a:rPr sz="1300" b="0">
-                          <a:solidFill>
-                            <a:srgbClr val="9DA9B5"/>
-                          </a:solidFill>
-                          <a:latin typeface="Arial"/>
-                        </a:rPr>
-                        <a:t>0.47 (NS)</a:t>
-                      </a:r>
-                    </a:p>
-                  </a:txBody>
-                  <a:tcPr anchor="ctr" marL="73152" marR="73152" marT="25400" marB="25400">
-                    <a:solidFill>
-                      <a:srgbClr val="0F141A"/>
-                    </a:solidFill>
-                  </a:tcPr>
-                </a:tc>
-                <a:tc>
-                  <a:txBody>
-                    <a:bodyPr/>
-                    <a:lstStyle/>
-                    <a:p>
-                      <a:pPr algn="ctr"/>
-                      <a:r>
-                        <a:rPr sz="1300" b="0">
-                          <a:solidFill>
-                            <a:srgbClr val="9DA9B5"/>
-                          </a:solidFill>
-                          <a:latin typeface="Arial"/>
-                        </a:rPr>
-                        <a:t>—</a:t>
-                      </a:r>
-                    </a:p>
-                  </a:txBody>
-                  <a:tcPr anchor="ctr" marL="73152" marR="73152" marT="25400" marB="25400">
-                    <a:solidFill>
-                      <a:srgbClr val="0F141A"/>
-                    </a:solidFill>
-                  </a:tcPr>
-                </a:tc>
-              </a:tr>
-              <a:tr h="329184">
-                <a:tc>
-                  <a:txBody>
-                    <a:bodyPr/>
-                    <a:lstStyle/>
-                    <a:p>
-                      <a:pPr algn="l"/>
-                      <a:r>
-                        <a:rPr sz="1300" b="0">
-                          <a:solidFill>
-                            <a:srgbClr val="ECEFF3"/>
-                          </a:solidFill>
-                          <a:latin typeface="Arial"/>
-                        </a:rPr>
-                        <a:t>75th pct (q0.75)</a:t>
-                      </a:r>
-                    </a:p>
-                  </a:txBody>
-                  <a:tcPr anchor="ctr" marL="73152" marR="73152" marT="25400" marB="25400">
-                    <a:solidFill>
-                      <a:srgbClr val="0F141A"/>
-                    </a:solidFill>
-                  </a:tcPr>
-                </a:tc>
-                <a:tc>
-                  <a:txBody>
-                    <a:bodyPr/>
-                    <a:lstStyle/>
-                    <a:p>
-                      <a:pPr algn="ctr"/>
-                      <a:r>
-                        <a:rPr sz="1300" b="0">
-                          <a:solidFill>
-                            <a:srgbClr val="9DA9B5"/>
-                          </a:solidFill>
-                          <a:latin typeface="Arial"/>
-                        </a:rPr>
-                        <a:t>&lt;0.001</a:t>
-                      </a:r>
-                    </a:p>
-                  </a:txBody>
-                  <a:tcPr anchor="ctr" marL="73152" marR="73152" marT="25400" marB="25400">
-                    <a:solidFill>
-                      <a:srgbClr val="0F141A"/>
-                    </a:solidFill>
-                  </a:tcPr>
-                </a:tc>
-                <a:tc>
-                  <a:txBody>
-                    <a:bodyPr/>
-                    <a:lstStyle/>
-                    <a:p>
-                      <a:pPr algn="ctr"/>
-                      <a:r>
-                        <a:rPr sz="1300" b="0">
-                          <a:solidFill>
-                            <a:srgbClr val="9DA9B5"/>
-                          </a:solidFill>
-                          <a:latin typeface="Arial"/>
-                        </a:rPr>
-                        <a:t>+3,408 mm³</a:t>
-                      </a:r>
-                    </a:p>
-                  </a:txBody>
-                  <a:tcPr anchor="ctr" marL="73152" marR="73152" marT="25400" marB="25400">
-                    <a:solidFill>
-                      <a:srgbClr val="0F141A"/>
-                    </a:solidFill>
-                  </a:tcPr>
-                </a:tc>
-              </a:tr>
-            </a:tbl>
-          </a:graphicData>
-        </a:graphic>
-      </p:graphicFrame>
+              <a:t>). Correlated with BAC (ρ=0.089, p=0.001).</a:t>
+            </a:r>
+          </a:p>
+        </p:txBody>
+      </p:sp>
+      <p:sp>
+        <p:nvSpPr>
+          <p:cNvPr id="7" name="Rectangle 6"/>
+          <p:cNvSpPr/>
+          <p:nvPr/>
+        </p:nvSpPr>
+        <p:spPr>
+          <a:xfrm>
+            <a:off x="777240" y="3611880"/>
+            <a:ext cx="5120640" cy="457200"/>
+          </a:xfrm>
+          <a:prstGeom prst="rect">
+            <a:avLst/>
+          </a:prstGeom>
+          <a:solidFill>
+            <a:srgbClr val="1B232D"/>
+          </a:solidFill>
+          <a:ln>
+            <a:noFill/>
+          </a:ln>
+          <a:effectLst/>
+        </p:spPr>
+        <p:style>
+          <a:lnRef idx="1">
+            <a:schemeClr val="accent1"/>
+          </a:lnRef>
+          <a:fillRef idx="3">
+            <a:schemeClr val="accent1"/>
+          </a:fillRef>
+          <a:effectRef idx="2">
+            <a:schemeClr val="accent1"/>
+          </a:effectRef>
+          <a:fontRef idx="minor">
+            <a:schemeClr val="lt1"/>
+          </a:fontRef>
+        </p:style>
+        <p:txBody>
+          <a:bodyPr rtlCol="0" anchor="ctr"/>
+          <a:lstStyle/>
+          <a:p>
+            <a:pPr algn="ctr"/>
+          </a:p>
+        </p:txBody>
+      </p:sp>
       <p:sp>
         <p:nvSpPr>
           <p:cNvPr id="8" name="TextBox 7"/>
@@ -8721,8 +8599,378 @@
         </p:nvSpPr>
         <p:spPr>
           <a:xfrm>
-            <a:off x="777240" y="5486400"/>
-            <a:ext cx="10607040" cy="457200"/>
+            <a:off x="886968" y="3611880"/>
+            <a:ext cx="3566160" cy="457200"/>
+          </a:xfrm>
+          <a:prstGeom prst="rect">
+            <a:avLst/>
+          </a:prstGeom>
+          <a:noFill/>
+        </p:spPr>
+        <p:txBody>
+          <a:bodyPr wrap="square" anchor="ctr" lIns="0" rIns="0" tIns="0" bIns="0">
+            <a:spAutoFit/>
+          </a:bodyPr>
+          <a:lstStyle/>
+          <a:p>
+            <a:pPr algn="l">
+              <a:lnSpc>
+                <a:spcPct val="100000"/>
+              </a:lnSpc>
+            </a:pPr>
+            <a:r>
+              <a:rPr sz="1000" b="0" i="0">
+                <a:solidFill>
+                  <a:srgbClr val="9DA9B5"/>
+                </a:solidFill>
+                <a:latin typeface="Consolas"/>
+              </a:rPr>
+              <a:t>HIGH BAC VS ZERO (ΔCCC)</a:t>
+            </a:r>
+          </a:p>
+        </p:txBody>
+      </p:sp>
+      <p:sp>
+        <p:nvSpPr>
+          <p:cNvPr id="9" name="TextBox 8"/>
+          <p:cNvSpPr txBox="1"/>
+          <p:nvPr/>
+        </p:nvSpPr>
+        <p:spPr>
+          <a:xfrm>
+            <a:off x="4343400" y="3611880"/>
+            <a:ext cx="1444751" cy="457200"/>
+          </a:xfrm>
+          <a:prstGeom prst="rect">
+            <a:avLst/>
+          </a:prstGeom>
+          <a:noFill/>
+        </p:spPr>
+        <p:txBody>
+          <a:bodyPr wrap="square" anchor="ctr" lIns="0" rIns="0" tIns="0" bIns="0">
+            <a:spAutoFit/>
+          </a:bodyPr>
+          <a:lstStyle/>
+          <a:p>
+            <a:pPr algn="r">
+              <a:lnSpc>
+                <a:spcPct val="100000"/>
+              </a:lnSpc>
+            </a:pPr>
+            <a:r>
+              <a:rPr sz="1000" b="0" i="0">
+                <a:solidFill>
+                  <a:srgbClr val="9DA9B5"/>
+                </a:solidFill>
+                <a:latin typeface="Consolas"/>
+              </a:rPr>
+              <a:t>ADJ. P</a:t>
+            </a:r>
+          </a:p>
+        </p:txBody>
+      </p:sp>
+      <p:sp>
+        <p:nvSpPr>
+          <p:cNvPr id="10" name="TextBox 9"/>
+          <p:cNvSpPr txBox="1"/>
+          <p:nvPr/>
+        </p:nvSpPr>
+        <p:spPr>
+          <a:xfrm>
+            <a:off x="886968" y="4069080"/>
+            <a:ext cx="3566160" cy="457200"/>
+          </a:xfrm>
+          <a:prstGeom prst="rect">
+            <a:avLst/>
+          </a:prstGeom>
+          <a:noFill/>
+        </p:spPr>
+        <p:txBody>
+          <a:bodyPr wrap="square" anchor="ctr" lIns="0" rIns="0" tIns="0" bIns="0">
+            <a:spAutoFit/>
+          </a:bodyPr>
+          <a:lstStyle/>
+          <a:p>
+            <a:pPr algn="l">
+              <a:lnSpc>
+                <a:spcPct val="100000"/>
+              </a:lnSpc>
+            </a:pPr>
+            <a:r>
+              <a:rPr sz="1300" b="0" i="0">
+                <a:solidFill>
+                  <a:srgbClr val="9DA9B5"/>
+                </a:solidFill>
+                <a:latin typeface="Arial"/>
+              </a:rPr>
+              <a:t>Median (q0.50)</a:t>
+            </a:r>
+          </a:p>
+        </p:txBody>
+      </p:sp>
+      <p:sp>
+        <p:nvSpPr>
+          <p:cNvPr id="11" name="TextBox 10"/>
+          <p:cNvSpPr txBox="1"/>
+          <p:nvPr/>
+        </p:nvSpPr>
+        <p:spPr>
+          <a:xfrm>
+            <a:off x="4343400" y="4069080"/>
+            <a:ext cx="1444751" cy="457200"/>
+          </a:xfrm>
+          <a:prstGeom prst="rect">
+            <a:avLst/>
+          </a:prstGeom>
+          <a:noFill/>
+        </p:spPr>
+        <p:txBody>
+          <a:bodyPr wrap="square" anchor="ctr" lIns="0" rIns="0" tIns="0" bIns="0">
+            <a:spAutoFit/>
+          </a:bodyPr>
+          <a:lstStyle/>
+          <a:p>
+            <a:pPr algn="r">
+              <a:lnSpc>
+                <a:spcPct val="100000"/>
+              </a:lnSpc>
+            </a:pPr>
+            <a:r>
+              <a:rPr sz="1300" b="0" i="0">
+                <a:solidFill>
+                  <a:srgbClr val="9DA9B5"/>
+                </a:solidFill>
+                <a:latin typeface="Arial"/>
+              </a:rPr>
+              <a:t>NS · 0.47</a:t>
+            </a:r>
+          </a:p>
+        </p:txBody>
+      </p:sp>
+      <p:sp>
+        <p:nvSpPr>
+          <p:cNvPr id="12" name="Rectangle 11"/>
+          <p:cNvSpPr/>
+          <p:nvPr/>
+        </p:nvSpPr>
+        <p:spPr>
+          <a:xfrm>
+            <a:off x="777240" y="4526280"/>
+            <a:ext cx="5120640" cy="457200"/>
+          </a:xfrm>
+          <a:prstGeom prst="rect">
+            <a:avLst/>
+          </a:prstGeom>
+          <a:solidFill>
+            <a:srgbClr val="222C37"/>
+          </a:solidFill>
+          <a:ln>
+            <a:noFill/>
+          </a:ln>
+          <a:effectLst/>
+        </p:spPr>
+        <p:style>
+          <a:lnRef idx="1">
+            <a:schemeClr val="accent1"/>
+          </a:lnRef>
+          <a:fillRef idx="3">
+            <a:schemeClr val="accent1"/>
+          </a:fillRef>
+          <a:effectRef idx="2">
+            <a:schemeClr val="accent1"/>
+          </a:effectRef>
+          <a:fontRef idx="minor">
+            <a:schemeClr val="lt1"/>
+          </a:fontRef>
+        </p:style>
+        <p:txBody>
+          <a:bodyPr rtlCol="0" anchor="ctr"/>
+          <a:lstStyle/>
+          <a:p>
+            <a:pPr algn="ctr"/>
+          </a:p>
+        </p:txBody>
+      </p:sp>
+      <p:sp>
+        <p:nvSpPr>
+          <p:cNvPr id="13" name="TextBox 12"/>
+          <p:cNvSpPr txBox="1"/>
+          <p:nvPr/>
+        </p:nvSpPr>
+        <p:spPr>
+          <a:xfrm>
+            <a:off x="886968" y="4526280"/>
+            <a:ext cx="3566160" cy="457200"/>
+          </a:xfrm>
+          <a:prstGeom prst="rect">
+            <a:avLst/>
+          </a:prstGeom>
+          <a:noFill/>
+        </p:spPr>
+        <p:txBody>
+          <a:bodyPr wrap="square" anchor="ctr" lIns="0" rIns="0" tIns="0" bIns="0">
+            <a:spAutoFit/>
+          </a:bodyPr>
+          <a:lstStyle/>
+          <a:p>
+            <a:pPr algn="l">
+              <a:lnSpc>
+                <a:spcPct val="100000"/>
+              </a:lnSpc>
+            </a:pPr>
+            <a:r>
+              <a:rPr sz="1300" b="1" i="0">
+                <a:solidFill>
+                  <a:srgbClr val="ECEFF3"/>
+                </a:solidFill>
+                <a:latin typeface="Arial"/>
+              </a:rPr>
+              <a:t>75th pct (q0.75)  </a:t>
+            </a:r>
+            <a:r>
+              <a:rPr sz="1300" b="1" i="0">
+                <a:solidFill>
+                  <a:srgbClr val="E7AC51"/>
+                </a:solidFill>
+                <a:latin typeface="Arial"/>
+              </a:rPr>
+              <a:t>+3,408 mm³</a:t>
+            </a:r>
+          </a:p>
+        </p:txBody>
+      </p:sp>
+      <p:sp>
+        <p:nvSpPr>
+          <p:cNvPr id="14" name="TextBox 13"/>
+          <p:cNvSpPr txBox="1"/>
+          <p:nvPr/>
+        </p:nvSpPr>
+        <p:spPr>
+          <a:xfrm>
+            <a:off x="4343400" y="4526280"/>
+            <a:ext cx="1444751" cy="457200"/>
+          </a:xfrm>
+          <a:prstGeom prst="rect">
+            <a:avLst/>
+          </a:prstGeom>
+          <a:noFill/>
+        </p:spPr>
+        <p:txBody>
+          <a:bodyPr wrap="square" anchor="ctr" lIns="0" rIns="0" tIns="0" bIns="0">
+            <a:spAutoFit/>
+          </a:bodyPr>
+          <a:lstStyle/>
+          <a:p>
+            <a:pPr algn="r">
+              <a:lnSpc>
+                <a:spcPct val="100000"/>
+              </a:lnSpc>
+            </a:pPr>
+            <a:r>
+              <a:rPr sz="1300" b="1" i="0">
+                <a:solidFill>
+                  <a:srgbClr val="ECEFF3"/>
+                </a:solidFill>
+                <a:latin typeface="Arial"/>
+              </a:rPr>
+              <a:t>&lt;0.001</a:t>
+            </a:r>
+          </a:p>
+        </p:txBody>
+      </p:sp>
+      <p:sp>
+        <p:nvSpPr>
+          <p:cNvPr id="15" name="Rectangle 14"/>
+          <p:cNvSpPr/>
+          <p:nvPr/>
+        </p:nvSpPr>
+        <p:spPr>
+          <a:xfrm>
+            <a:off x="777240" y="5212080"/>
+            <a:ext cx="27432" cy="640080"/>
+          </a:xfrm>
+          <a:prstGeom prst="rect">
+            <a:avLst/>
+          </a:prstGeom>
+          <a:solidFill>
+            <a:srgbClr val="E7AC51"/>
+          </a:solidFill>
+          <a:ln>
+            <a:noFill/>
+          </a:ln>
+          <a:effectLst/>
+        </p:spPr>
+        <p:style>
+          <a:lnRef idx="1">
+            <a:schemeClr val="accent1"/>
+          </a:lnRef>
+          <a:fillRef idx="3">
+            <a:schemeClr val="accent1"/>
+          </a:fillRef>
+          <a:effectRef idx="2">
+            <a:schemeClr val="accent1"/>
+          </a:effectRef>
+          <a:fontRef idx="minor">
+            <a:schemeClr val="lt1"/>
+          </a:fontRef>
+        </p:style>
+        <p:txBody>
+          <a:bodyPr rtlCol="0" anchor="ctr"/>
+          <a:lstStyle/>
+          <a:p>
+            <a:pPr algn="ctr"/>
+          </a:p>
+        </p:txBody>
+      </p:sp>
+      <p:sp>
+        <p:nvSpPr>
+          <p:cNvPr id="16" name="TextBox 15"/>
+          <p:cNvSpPr txBox="1"/>
+          <p:nvPr/>
+        </p:nvSpPr>
+        <p:spPr>
+          <a:xfrm>
+            <a:off x="960120" y="5212080"/>
+            <a:ext cx="5486400" cy="640080"/>
+          </a:xfrm>
+          <a:prstGeom prst="rect">
+            <a:avLst/>
+          </a:prstGeom>
+          <a:noFill/>
+        </p:spPr>
+        <p:txBody>
+          <a:bodyPr wrap="square" anchor="t" lIns="0" rIns="0" tIns="0" bIns="0">
+            <a:spAutoFit/>
+          </a:bodyPr>
+          <a:lstStyle/>
+          <a:p>
+            <a:pPr algn="l">
+              <a:lnSpc>
+                <a:spcPct val="135000"/>
+              </a:lnSpc>
+            </a:pPr>
+            <a:r>
+              <a:rPr sz="1350" b="0" i="0">
+                <a:solidFill>
+                  <a:srgbClr val="ECEFF3"/>
+                </a:solidFill>
+                <a:latin typeface="Arial"/>
+              </a:rPr>
+              <a:t>Vascular + valvular + skeletal — one free mammographic finding.</a:t>
+            </a:r>
+          </a:p>
+        </p:txBody>
+      </p:sp>
+      <p:sp>
+        <p:nvSpPr>
+          <p:cNvPr id="17" name="TextBox 16"/>
+          <p:cNvSpPr txBox="1"/>
+          <p:nvPr/>
+        </p:nvSpPr>
+        <p:spPr>
+          <a:xfrm>
+            <a:off x="777240" y="5989320"/>
+            <a:ext cx="5852160" cy="457200"/>
           </a:xfrm>
           <a:prstGeom prst="rect">
             <a:avLst/>
@@ -8748,6 +8996,122 @@
                 <a:latin typeface="Consolas"/>
               </a:rPr>
               <a:t>[your group], RSNA 2026 abstract (BAC–CCC) · quantile regression, adj. age + DM.</a:t>
+            </a:r>
+          </a:p>
+        </p:txBody>
+      </p:sp>
+      <p:sp>
+        <p:nvSpPr>
+          <p:cNvPr id="18" name="Rounded Rectangle 17"/>
+          <p:cNvSpPr/>
+          <p:nvPr/>
+        </p:nvSpPr>
+        <p:spPr>
+          <a:xfrm>
+            <a:off x="6858000" y="1188720"/>
+            <a:ext cx="4846320" cy="4572000"/>
+          </a:xfrm>
+          <a:prstGeom prst="roundRect">
+            <a:avLst/>
+          </a:prstGeom>
+          <a:noFill/>
+          <a:ln w="12700">
+            <a:solidFill>
+              <a:srgbClr val="C98A2E"/>
+            </a:solidFill>
+            <a:prstDash val="dash"/>
+          </a:ln>
+          <a:effectLst/>
+        </p:spPr>
+        <p:style>
+          <a:lnRef idx="1">
+            <a:schemeClr val="accent1"/>
+          </a:lnRef>
+          <a:fillRef idx="3">
+            <a:schemeClr val="accent1"/>
+          </a:fillRef>
+          <a:effectRef idx="2">
+            <a:schemeClr val="accent1"/>
+          </a:effectRef>
+          <a:fontRef idx="minor">
+            <a:schemeClr val="lt1"/>
+          </a:fontRef>
+        </p:style>
+        <p:txBody>
+          <a:bodyPr rtlCol="0" anchor="ctr" wrap="square"/>
+          <a:lstStyle/>
+          <a:p>
+            <a:pPr algn="ctr">
+              <a:lnSpc>
+                <a:spcPct val="100000"/>
+              </a:lnSpc>
+            </a:pPr>
+            <a:r>
+              <a:rPr sz="1100" b="0" i="0">
+                <a:solidFill>
+                  <a:srgbClr val="E7AC51"/>
+                </a:solidFill>
+                <a:latin typeface="Consolas"/>
+              </a:rPr>
+              <a:t>COSTOCHONDRAL CALCIFICATION</a:t>
+            </a:r>
+          </a:p>
+          <a:p>
+            <a:pPr algn="ctr">
+              <a:lnSpc>
+                <a:spcPct val="100000"/>
+              </a:lnSpc>
+              <a:spcBef>
+                <a:spcPts val="300"/>
+              </a:spcBef>
+            </a:pPr>
+            <a:r>
+              <a:rPr sz="900" b="0" i="0">
+                <a:solidFill>
+                  <a:srgbClr val="5C6975"/>
+                </a:solidFill>
+                <a:latin typeface="Consolas"/>
+              </a:rPr>
+              <a:t>[ drop in — confirm reuse rights ]</a:t>
+            </a:r>
+          </a:p>
+        </p:txBody>
+      </p:sp>
+      <p:sp>
+        <p:nvSpPr>
+          <p:cNvPr id="19" name="TextBox 18"/>
+          <p:cNvSpPr txBox="1"/>
+          <p:nvPr/>
+        </p:nvSpPr>
+        <p:spPr>
+          <a:xfrm>
+            <a:off x="6858000" y="5852160"/>
+            <a:ext cx="4846320" cy="274320"/>
+          </a:xfrm>
+          <a:prstGeom prst="rect">
+            <a:avLst/>
+          </a:prstGeom>
+          <a:noFill/>
+        </p:spPr>
+        <p:txBody>
+          <a:bodyPr wrap="square" anchor="t" lIns="0" rIns="0" tIns="0" bIns="0">
+            <a:spAutoFit/>
+          </a:bodyPr>
+          <a:lstStyle/>
+          <a:p>
+            <a:pPr algn="ctr">
+              <a:lnSpc>
+                <a:spcPct val="100000"/>
+              </a:lnSpc>
+            </a:pPr>
+            <a:r>
+              <a:rPr sz="900" b="0" i="0">
+                <a:solidFill>
+                  <a:srgbClr val="5C6975"/>
+                </a:solidFill>
+                <a:latin typeface="Consolas"/>
+              </a:rPr>
+              <a:t>Illustrative. Source: Sarıyıldız et al., via ResearchGate.</a:t>
             </a:r>
           </a:p>
         </p:txBody>
@@ -9267,7 +9631,7 @@
         </p:nvSpPr>
         <p:spPr>
           <a:xfrm>
-            <a:off x="777240" y="1005840"/>
+            <a:off x="777240" y="960120"/>
             <a:ext cx="10607040" cy="1280160"/>
           </a:xfrm>
           <a:prstGeom prst="rect">
@@ -9287,7 +9651,7 @@
               </a:lnSpc>
             </a:pPr>
             <a:r>
-              <a:rPr sz="2800" b="1" i="0">
+              <a:rPr sz="2700" b="1" i="0">
                 <a:solidFill>
                   <a:srgbClr val="ECEFF3"/>
                 </a:solidFill>
@@ -9296,7 +9660,7 @@
               <a:t>2026: two prospective studies show </a:t>
             </a:r>
             <a:r>
-              <a:rPr sz="2800" b="1" i="0">
+              <a:rPr sz="2700" b="1" i="0">
                 <a:solidFill>
                   <a:srgbClr val="E7AC51"/>
                 </a:solidFill>
@@ -9316,7 +9680,7 @@
         <p:spPr>
           <a:xfrm>
             <a:off x="777240" y="2148840"/>
-            <a:ext cx="5212080" cy="2743200"/>
+            <a:ext cx="5212080" cy="2331720"/>
           </a:xfrm>
           <a:prstGeom prst="roundRect">
             <a:avLst/>
@@ -9324,9 +9688,9 @@
           <a:solidFill>
             <a:srgbClr val="1B232D"/>
           </a:solidFill>
-          <a:ln w="13970">
+          <a:ln w="9525">
             <a:solidFill>
-              <a:srgbClr val="C98A2E"/>
+              <a:srgbClr val="2A333D"/>
             </a:solidFill>
           </a:ln>
           <a:effectLst/>
@@ -9346,7 +9710,7 @@
           </a:fontRef>
         </p:style>
         <p:txBody>
-          <a:bodyPr rtlCol="0" anchor="ctr" wrap="square" lIns="256032" rIns="219456" tIns="201168"/>
+          <a:bodyPr rtlCol="0" anchor="ctr" wrap="square" lIns="274320" rIns="219456" tIns="182880"/>
           <a:lstStyle/>
           <a:p>
             <a:pPr algn="l">
@@ -9355,13 +9719,41 @@
               </a:lnSpc>
             </a:pPr>
             <a:r>
-              <a:rPr sz="1200" b="1" i="0">
-                <a:solidFill>
-                  <a:srgbClr val="E7AC51"/>
+              <a:rPr sz="1100" b="0" i="0">
+                <a:solidFill>
+                  <a:srgbClr val="5FB7C9"/>
                 </a:solidFill>
                 <a:latin typeface="Consolas"/>
               </a:rPr>
               <a:t>MASAI · SWEDEN · RCT (~105,000)</a:t>
+            </a:r>
+          </a:p>
+          <a:p>
+            <a:pPr algn="l">
+              <a:lnSpc>
+                <a:spcPct val="118000"/>
+              </a:lnSpc>
+              <a:spcBef>
+                <a:spcPts val="800"/>
+              </a:spcBef>
+            </a:pPr>
+            <a:r>
+              <a:rPr sz="1600" b="1" i="0">
+                <a:solidFill>
+                  <a:srgbClr val="ECEFF3"/>
+                </a:solidFill>
+                <a:latin typeface="Arial"/>
+              </a:rPr>
+              <a:t>Interval cancers non-inferior</a:t>
+            </a:r>
+            <a:r>
+              <a:rPr sz="1600" b="0" i="0">
+                <a:solidFill>
+                  <a:srgbClr val="5C6975"/>
+                </a:solidFill>
+                <a:latin typeface="Arial"/>
+              </a:rPr>
+              <a:t> (ratio 0.88)</a:t>
             </a:r>
           </a:p>
           <a:p>
@@ -9370,35 +9762,203 @@
                 <a:spcPct val="130000"/>
               </a:lnSpc>
               <a:spcBef>
+                <a:spcPts val="700"/>
+              </a:spcBef>
+            </a:pPr>
+            <a:r>
+              <a:rPr sz="1300" b="0" i="0">
+                <a:solidFill>
+                  <a:srgbClr val="9DA9B5"/>
+                </a:solidFill>
+                <a:latin typeface="Arial"/>
+              </a:rPr>
+              <a:t>Sensitivity </a:t>
+            </a:r>
+            <a:r>
+              <a:rPr sz="1300" b="1" i="0">
+                <a:solidFill>
+                  <a:srgbClr val="ECEFF3"/>
+                </a:solidFill>
+                <a:latin typeface="Arial"/>
+              </a:rPr>
+              <a:t>80.5%</a:t>
+            </a:r>
+            <a:r>
+              <a:rPr sz="1300" b="0" i="0">
+                <a:solidFill>
+                  <a:srgbClr val="9DA9B5"/>
+                </a:solidFill>
+                <a:latin typeface="Arial"/>
+              </a:rPr>
+              <a:t> vs 73.8% at matched specificity · </a:t>
+            </a:r>
+            <a:r>
+              <a:rPr sz="1300" b="1" i="0">
+                <a:solidFill>
+                  <a:srgbClr val="ECEFF3"/>
+                </a:solidFill>
+                <a:latin typeface="Arial"/>
+              </a:rPr>
+              <a:t>~44%</a:t>
+            </a:r>
+            <a:r>
+              <a:rPr sz="1300" b="0" i="0">
+                <a:solidFill>
+                  <a:srgbClr val="9DA9B5"/>
+                </a:solidFill>
+                <a:latin typeface="Arial"/>
+              </a:rPr>
+              <a:t> less reading workload.</a:t>
+            </a:r>
+          </a:p>
+          <a:p>
+            <a:pPr algn="l">
+              <a:lnSpc>
+                <a:spcPct val="100000"/>
+              </a:lnSpc>
+              <a:spcBef>
+                <a:spcPts val="900"/>
+              </a:spcBef>
+            </a:pPr>
+            <a:r>
+              <a:rPr sz="900" b="0" i="0">
+                <a:solidFill>
+                  <a:srgbClr val="5C6975"/>
+                </a:solidFill>
+                <a:latin typeface="Consolas"/>
+              </a:rPr>
+              <a:t>Gommers/Lång et al., Lancet 2026;407:505–514</a:t>
+            </a:r>
+          </a:p>
+        </p:txBody>
+      </p:sp>
+      <p:sp>
+        <p:nvSpPr>
+          <p:cNvPr id="7" name="Rectangle 6"/>
+          <p:cNvSpPr/>
+          <p:nvPr/>
+        </p:nvSpPr>
+        <p:spPr>
+          <a:xfrm>
+            <a:off x="777240" y="2148840"/>
+            <a:ext cx="45720" cy="2331720"/>
+          </a:xfrm>
+          <a:prstGeom prst="rect">
+            <a:avLst/>
+          </a:prstGeom>
+          <a:solidFill>
+            <a:srgbClr val="5FB7C9"/>
+          </a:solidFill>
+          <a:ln>
+            <a:noFill/>
+          </a:ln>
+          <a:effectLst/>
+        </p:spPr>
+        <p:style>
+          <a:lnRef idx="1">
+            <a:schemeClr val="accent1"/>
+          </a:lnRef>
+          <a:fillRef idx="3">
+            <a:schemeClr val="accent1"/>
+          </a:fillRef>
+          <a:effectRef idx="2">
+            <a:schemeClr val="accent1"/>
+          </a:effectRef>
+          <a:fontRef idx="minor">
+            <a:schemeClr val="lt1"/>
+          </a:fontRef>
+        </p:style>
+        <p:txBody>
+          <a:bodyPr rtlCol="0" anchor="ctr"/>
+          <a:lstStyle/>
+          <a:p>
+            <a:pPr algn="ctr"/>
+          </a:p>
+        </p:txBody>
+      </p:sp>
+      <p:sp>
+        <p:nvSpPr>
+          <p:cNvPr id="8" name="Rounded Rectangle 7"/>
+          <p:cNvSpPr/>
+          <p:nvPr/>
+        </p:nvSpPr>
+        <p:spPr>
+          <a:xfrm>
+            <a:off x="6172200" y="2148840"/>
+            <a:ext cx="5212080" cy="2331720"/>
+          </a:xfrm>
+          <a:prstGeom prst="roundRect">
+            <a:avLst/>
+          </a:prstGeom>
+          <a:solidFill>
+            <a:srgbClr val="1B232D"/>
+          </a:solidFill>
+          <a:ln w="9525">
+            <a:solidFill>
+              <a:srgbClr val="2A333D"/>
+            </a:solidFill>
+          </a:ln>
+          <a:effectLst/>
+        </p:spPr>
+        <p:style>
+          <a:lnRef idx="1">
+            <a:schemeClr val="accent1"/>
+          </a:lnRef>
+          <a:fillRef idx="3">
+            <a:schemeClr val="accent1"/>
+          </a:fillRef>
+          <a:effectRef idx="2">
+            <a:schemeClr val="accent1"/>
+          </a:effectRef>
+          <a:fontRef idx="minor">
+            <a:schemeClr val="lt1"/>
+          </a:fontRef>
+        </p:style>
+        <p:txBody>
+          <a:bodyPr rtlCol="0" anchor="ctr" wrap="square" lIns="274320" rIns="219456" tIns="182880"/>
+          <a:lstStyle/>
+          <a:p>
+            <a:pPr algn="l">
+              <a:lnSpc>
+                <a:spcPct val="100000"/>
+              </a:lnSpc>
+            </a:pPr>
+            <a:r>
+              <a:rPr sz="1100" b="0" i="0">
+                <a:solidFill>
+                  <a:srgbClr val="5FB7C9"/>
+                </a:solidFill>
+                <a:latin typeface="Consolas"/>
+              </a:rPr>
+              <a:t>PRAIM · GERMANY · REAL-WORLD (463,000)</a:t>
+            </a:r>
+          </a:p>
+          <a:p>
+            <a:pPr algn="l">
+              <a:lnSpc>
+                <a:spcPct val="118000"/>
+              </a:lnSpc>
+              <a:spcBef>
                 <a:spcPts val="800"/>
               </a:spcBef>
             </a:pPr>
             <a:r>
-              <a:rPr sz="1400" b="0" i="0">
-                <a:solidFill>
-                  <a:srgbClr val="9DA9B5"/>
-                </a:solidFill>
-                <a:latin typeface="Arial"/>
-              </a:rPr>
-              <a:t>Interval cancers </a:t>
-            </a:r>
-            <a:r>
-              <a:rPr sz="1400" b="1" i="0">
+              <a:rPr sz="1600" b="1" i="0">
+                <a:solidFill>
+                  <a:srgbClr val="E7AC51"/>
+                </a:solidFill>
+                <a:latin typeface="Arial"/>
+              </a:rPr>
+              <a:t>+17.6%</a:t>
+            </a:r>
+            <a:r>
+              <a:rPr sz="1600" b="1" i="0">
                 <a:solidFill>
                   <a:srgbClr val="ECEFF3"/>
                 </a:solidFill>
                 <a:latin typeface="Arial"/>
               </a:rPr>
-              <a:t>non-inferior</a:t>
-            </a:r>
-            <a:r>
-              <a:rPr sz="1400" b="0" i="0">
-                <a:solidFill>
-                  <a:srgbClr val="9DA9B5"/>
-                </a:solidFill>
-                <a:latin typeface="Arial"/>
-              </a:rPr>
-              <a:t> (ratio 0.88)</a:t>
+              <a:t> cancers detected</a:t>
             </a:r>
           </a:p>
           <a:p>
@@ -9407,63 +9967,35 @@
                 <a:spcPct val="130000"/>
               </a:lnSpc>
               <a:spcBef>
-                <a:spcPts val="800"/>
+                <a:spcPts val="700"/>
               </a:spcBef>
             </a:pPr>
             <a:r>
-              <a:rPr sz="1400" b="0" i="0">
+              <a:rPr sz="1300" b="0" i="0">
                 <a:solidFill>
                   <a:srgbClr val="9DA9B5"/>
                 </a:solidFill>
                 <a:latin typeface="Arial"/>
               </a:rPr>
-              <a:t>Sensitivity </a:t>
-            </a:r>
-            <a:r>
-              <a:rPr sz="1400" b="1" i="0">
-                <a:solidFill>
-                  <a:srgbClr val="E7AC51"/>
-                </a:solidFill>
-                <a:latin typeface="Arial"/>
-              </a:rPr>
-              <a:t>80.5%</a:t>
-            </a:r>
-            <a:r>
-              <a:rPr sz="1400" b="0" i="0">
+              <a:t>Recall </a:t>
+            </a:r>
+            <a:r>
+              <a:rPr sz="1300" b="1" i="0">
+                <a:solidFill>
+                  <a:srgbClr val="ECEFF3"/>
+                </a:solidFill>
+                <a:latin typeface="Arial"/>
+              </a:rPr>
+              <a:t>non-inferior</a:t>
+            </a:r>
+            <a:r>
+              <a:rPr sz="1300" b="0" i="0">
                 <a:solidFill>
                   <a:srgbClr val="9DA9B5"/>
                 </a:solidFill>
                 <a:latin typeface="Arial"/>
               </a:rPr>
-              <a:t> vs 73.8% at matched specificity</a:t>
-            </a:r>
-          </a:p>
-          <a:p>
-            <a:pPr algn="l">
-              <a:lnSpc>
-                <a:spcPct val="130000"/>
-              </a:lnSpc>
-              <a:spcBef>
-                <a:spcPts val="800"/>
-              </a:spcBef>
-            </a:pPr>
-            <a:r>
-              <a:rPr sz="1400" b="1" i="0">
-                <a:solidFill>
-                  <a:srgbClr val="E7AC51"/>
-                </a:solidFill>
-                <a:latin typeface="Arial"/>
-              </a:rPr>
-              <a:t>~44%</a:t>
-            </a:r>
-            <a:r>
-              <a:rPr sz="1400" b="0" i="0">
-                <a:solidFill>
-                  <a:srgbClr val="9DA9B5"/>
-                </a:solidFill>
-                <a:latin typeface="Arial"/>
-              </a:rPr>
-              <a:t> less reading workload</a:t>
+              <a:t> · 6.7 vs 5.7 CDR / 1,000 · 12 sites, 119 radiologists.</a:t>
             </a:r>
           </a:p>
           <a:p>
@@ -9472,42 +10004,40 @@
                 <a:spcPct val="100000"/>
               </a:lnSpc>
               <a:spcBef>
-                <a:spcPts val="1000"/>
+                <a:spcPts val="900"/>
               </a:spcBef>
             </a:pPr>
             <a:r>
-              <a:rPr sz="950" b="0" i="0">
+              <a:rPr sz="900" b="0" i="0">
                 <a:solidFill>
                   <a:srgbClr val="5C6975"/>
                 </a:solidFill>
                 <a:latin typeface="Consolas"/>
               </a:rPr>
-              <a:t>Gommers/Lång et al., Lancet 2026;407:505–514</a:t>
-            </a:r>
-          </a:p>
-        </p:txBody>
-      </p:sp>
-      <p:sp>
-        <p:nvSpPr>
-          <p:cNvPr id="7" name="Rounded Rectangle 6"/>
+              <a:t>Eisemann et al., Nature Medicine 2025</a:t>
+            </a:r>
+          </a:p>
+        </p:txBody>
+      </p:sp>
+      <p:sp>
+        <p:nvSpPr>
+          <p:cNvPr id="9" name="Rectangle 8"/>
           <p:cNvSpPr/>
           <p:nvPr/>
         </p:nvSpPr>
         <p:spPr>
           <a:xfrm>
             <a:off x="6172200" y="2148840"/>
-            <a:ext cx="5212080" cy="2743200"/>
-          </a:xfrm>
-          <a:prstGeom prst="roundRect">
+            <a:ext cx="45720" cy="2331720"/>
+          </a:xfrm>
+          <a:prstGeom prst="rect">
             <a:avLst/>
           </a:prstGeom>
           <a:solidFill>
-            <a:srgbClr val="1B232D"/>
+            <a:srgbClr val="5FB7C9"/>
           </a:solidFill>
-          <a:ln w="13970">
-            <a:solidFill>
-              <a:srgbClr val="C98A2E"/>
-            </a:solidFill>
+          <a:ln>
+            <a:noFill/>
           </a:ln>
           <a:effectLst/>
         </p:spPr>
@@ -9526,139 +10056,67 @@
           </a:fontRef>
         </p:style>
         <p:txBody>
-          <a:bodyPr rtlCol="0" anchor="ctr" wrap="square" lIns="256032" rIns="219456" tIns="201168"/>
-          <a:lstStyle/>
-          <a:p>
-            <a:pPr algn="l">
-              <a:lnSpc>
-                <a:spcPct val="100000"/>
-              </a:lnSpc>
-            </a:pPr>
-            <a:r>
-              <a:rPr sz="1200" b="1" i="0">
-                <a:solidFill>
-                  <a:srgbClr val="E7AC51"/>
-                </a:solidFill>
-                <a:latin typeface="Consolas"/>
-              </a:rPr>
-              <a:t>PRAIM · GERMANY · REAL-WORLD (463,000)</a:t>
-            </a:r>
-          </a:p>
-          <a:p>
-            <a:pPr algn="l">
-              <a:lnSpc>
-                <a:spcPct val="130000"/>
-              </a:lnSpc>
-              <a:spcBef>
-                <a:spcPts val="800"/>
-              </a:spcBef>
-            </a:pPr>
-            <a:r>
-              <a:rPr sz="1400" b="1" i="0">
-                <a:solidFill>
-                  <a:srgbClr val="E7AC51"/>
-                </a:solidFill>
-                <a:latin typeface="Arial"/>
-              </a:rPr>
-              <a:t>+17.6%</a:t>
-            </a:r>
-            <a:r>
-              <a:rPr sz="1400" b="0" i="0">
-                <a:solidFill>
-                  <a:srgbClr val="9DA9B5"/>
-                </a:solidFill>
-                <a:latin typeface="Arial"/>
-              </a:rPr>
-              <a:t> cancers detected</a:t>
-            </a:r>
-          </a:p>
-          <a:p>
-            <a:pPr algn="l">
-              <a:lnSpc>
-                <a:spcPct val="130000"/>
-              </a:lnSpc>
-              <a:spcBef>
-                <a:spcPts val="800"/>
-              </a:spcBef>
-            </a:pPr>
-            <a:r>
-              <a:rPr sz="1400" b="0" i="0">
-                <a:solidFill>
-                  <a:srgbClr val="9DA9B5"/>
-                </a:solidFill>
-                <a:latin typeface="Arial"/>
-              </a:rPr>
-              <a:t>Recall </a:t>
-            </a:r>
-            <a:r>
-              <a:rPr sz="1400" b="1" i="0">
-                <a:solidFill>
-                  <a:srgbClr val="ECEFF3"/>
-                </a:solidFill>
-                <a:latin typeface="Arial"/>
-              </a:rPr>
-              <a:t>non-inferior</a:t>
-            </a:r>
-            <a:r>
-              <a:rPr sz="1400" b="0" i="0">
-                <a:solidFill>
-                  <a:srgbClr val="9DA9B5"/>
-                </a:solidFill>
-                <a:latin typeface="Arial"/>
-              </a:rPr>
-              <a:t> · 6.7 vs 5.7 CDR / 1,000</a:t>
-            </a:r>
-          </a:p>
-          <a:p>
-            <a:pPr algn="l">
-              <a:lnSpc>
-                <a:spcPct val="130000"/>
-              </a:lnSpc>
-              <a:spcBef>
-                <a:spcPts val="800"/>
-              </a:spcBef>
-            </a:pPr>
-            <a:r>
-              <a:rPr sz="1400" b="0" i="0">
-                <a:solidFill>
-                  <a:srgbClr val="9DA9B5"/>
-                </a:solidFill>
-                <a:latin typeface="Arial"/>
-              </a:rPr>
-              <a:t>12 sites · 119 radiologists</a:t>
-            </a:r>
-          </a:p>
-          <a:p>
-            <a:pPr algn="l">
-              <a:lnSpc>
-                <a:spcPct val="100000"/>
-              </a:lnSpc>
-              <a:spcBef>
-                <a:spcPts val="1000"/>
-              </a:spcBef>
-            </a:pPr>
-            <a:r>
-              <a:rPr sz="950" b="0" i="0">
-                <a:solidFill>
-                  <a:srgbClr val="5C6975"/>
-                </a:solidFill>
-                <a:latin typeface="Consolas"/>
-              </a:rPr>
-              <a:t>Eisemann et al., Nature Medicine 2025</a:t>
-            </a:r>
-          </a:p>
-        </p:txBody>
-      </p:sp>
-      <p:sp>
-        <p:nvSpPr>
-          <p:cNvPr id="8" name="TextBox 7"/>
+          <a:bodyPr rtlCol="0" anchor="ctr"/>
+          <a:lstStyle/>
+          <a:p>
+            <a:pPr algn="ctr"/>
+          </a:p>
+        </p:txBody>
+      </p:sp>
+      <p:sp>
+        <p:nvSpPr>
+          <p:cNvPr id="10" name="Rectangle 9"/>
+          <p:cNvSpPr/>
+          <p:nvPr/>
+        </p:nvSpPr>
+        <p:spPr>
+          <a:xfrm>
+            <a:off x="777240" y="4892040"/>
+            <a:ext cx="27432" cy="1188720"/>
+          </a:xfrm>
+          <a:prstGeom prst="rect">
+            <a:avLst/>
+          </a:prstGeom>
+          <a:solidFill>
+            <a:srgbClr val="E7AC51"/>
+          </a:solidFill>
+          <a:ln>
+            <a:noFill/>
+          </a:ln>
+          <a:effectLst/>
+        </p:spPr>
+        <p:style>
+          <a:lnRef idx="1">
+            <a:schemeClr val="accent1"/>
+          </a:lnRef>
+          <a:fillRef idx="3">
+            <a:schemeClr val="accent1"/>
+          </a:fillRef>
+          <a:effectRef idx="2">
+            <a:schemeClr val="accent1"/>
+          </a:effectRef>
+          <a:fontRef idx="minor">
+            <a:schemeClr val="lt1"/>
+          </a:fontRef>
+        </p:style>
+        <p:txBody>
+          <a:bodyPr rtlCol="0" anchor="ctr"/>
+          <a:lstStyle/>
+          <a:p>
+            <a:pPr algn="ctr"/>
+          </a:p>
+        </p:txBody>
+      </p:sp>
+      <p:sp>
+        <p:nvSpPr>
+          <p:cNvPr id="11" name="TextBox 10"/>
           <p:cNvSpPr txBox="1"/>
           <p:nvPr/>
         </p:nvSpPr>
         <p:spPr>
           <a:xfrm>
-            <a:off x="777240" y="5212080"/>
-            <a:ext cx="10607040" cy="1280160"/>
+            <a:off x="960120" y="4892040"/>
+            <a:ext cx="10424160" cy="1188720"/>
           </a:xfrm>
           <a:prstGeom prst="rect">
             <a:avLst/>
@@ -9677,7 +10135,7 @@
               </a:lnSpc>
             </a:pPr>
             <a:r>
-              <a:rPr sz="1300" b="0" i="0">
+              <a:rPr sz="1350" b="0" i="0">
                 <a:solidFill>
                   <a:srgbClr val="9DA9B5"/>
                 </a:solidFill>
@@ -9686,22 +10144,40 @@
               <a:t>A third is underway: </a:t>
             </a:r>
             <a:r>
-              <a:rPr sz="1300" b="1" i="0">
-                <a:solidFill>
-                  <a:srgbClr val="E7AC51"/>
+              <a:rPr sz="1350" b="1" i="0">
+                <a:solidFill>
+                  <a:srgbClr val="ECEFF3"/>
                 </a:solidFill>
                 <a:latin typeface="Arial"/>
               </a:rPr>
               <a:t>PRISM</a:t>
             </a:r>
             <a:r>
-              <a:rPr sz="1300" b="0" i="0">
+              <a:rPr sz="1350" b="0" i="0">
                 <a:solidFill>
                   <a:srgbClr val="9DA9B5"/>
                 </a:solidFill>
                 <a:latin typeface="Arial"/>
               </a:rPr>
-              <a:t> — the first large randomized trial of screening AI in the US (Transpara; $16M PCORI; 7 sites; recruiting). It tests the US single-reader workflow directly.</a:t>
+              <a:t> — the first large randomized trial of screening AI in the United States (Transpara; $16M PCORI; 7 sites; announced Sept 2025, recruiting). It tests the </a:t>
+            </a:r>
+            <a:r>
+              <a:rPr sz="1350" b="1" i="0">
+                <a:solidFill>
+                  <a:srgbClr val="ECEFF3"/>
+                </a:solidFill>
+                <a:latin typeface="Arial"/>
+              </a:rPr>
+              <a:t>US single-reader workflow</a:t>
+            </a:r>
+            <a:r>
+              <a:rPr sz="1350" b="0" i="0">
+                <a:solidFill>
+                  <a:srgbClr val="9DA9B5"/>
+                </a:solidFill>
+                <a:latin typeface="Arial"/>
+              </a:rPr>
+              <a:t> directly.</a:t>
             </a:r>
           </a:p>
         </p:txBody>
@@ -11440,8 +11916,8 @@
         </p:nvSpPr>
         <p:spPr>
           <a:xfrm>
-            <a:off x="777240" y="1005840"/>
-            <a:ext cx="10607040" cy="1280160"/>
+            <a:off x="777240" y="1371600"/>
+            <a:ext cx="5852160" cy="1280160"/>
           </a:xfrm>
           <a:prstGeom prst="rect">
             <a:avLst/>
@@ -11488,8 +11964,8 @@
         </p:nvSpPr>
         <p:spPr>
           <a:xfrm>
-            <a:off x="777240" y="2103120"/>
-            <a:ext cx="10241280" cy="822960"/>
+            <a:off x="777240" y="2468880"/>
+            <a:ext cx="5486400" cy="1097280"/>
           </a:xfrm>
           <a:prstGeom prst="rect">
             <a:avLst/>
@@ -11508,7 +11984,7 @@
               </a:lnSpc>
             </a:pPr>
             <a:r>
-              <a:rPr sz="1500" b="0" i="0">
+              <a:rPr sz="1400" b="0" i="0">
                 <a:solidFill>
                   <a:srgbClr val="9DA9B5"/>
                 </a:solidFill>
@@ -11517,7 +11993,7 @@
               <a:t>A commercial ICH detector looked strong overall — but sensitivity </a:t>
             </a:r>
             <a:r>
-              <a:rPr sz="1500" b="1" i="0">
+              <a:rPr sz="1400" b="1" i="0">
                 <a:solidFill>
                   <a:srgbClr val="ECEFF3"/>
                 </a:solidFill>
@@ -11526,7 +12002,7 @@
               <a:t>collapsed for subacute and chronic</a:t>
             </a:r>
             <a:r>
-              <a:rPr sz="1500" b="0" i="0">
+              <a:rPr sz="1400" b="0" i="0">
                 <a:solidFill>
                   <a:srgbClr val="9DA9B5"/>
                 </a:solidFill>
@@ -11535,7 +12011,7 @@
               <a:t> bleeds, and fell in the </a:t>
             </a:r>
             <a:r>
-              <a:rPr sz="1500" b="1" i="0">
+              <a:rPr sz="1400" b="1" i="0">
                 <a:solidFill>
                   <a:srgbClr val="ECEFF3"/>
                 </a:solidFill>
@@ -11544,7 +12020,7 @@
               <a:t>outpatient</a:t>
             </a:r>
             <a:r>
-              <a:rPr sz="1500" b="0" i="0">
+              <a:rPr sz="1400" b="0" i="0">
                 <a:solidFill>
                   <a:srgbClr val="9DA9B5"/>
                 </a:solidFill>
@@ -11563,8 +12039,8 @@
         </p:nvSpPr>
         <p:spPr>
           <a:xfrm>
-            <a:off x="777240" y="3383280"/>
-            <a:ext cx="2651760" cy="640080"/>
+            <a:off x="777240" y="3794760"/>
+            <a:ext cx="5852160" cy="457200"/>
           </a:xfrm>
           <a:prstGeom prst="rect">
             <a:avLst/>
@@ -11572,7 +12048,7 @@
           <a:noFill/>
         </p:spPr>
         <p:txBody>
-          <a:bodyPr wrap="square" anchor="t" lIns="0" rIns="0" tIns="0" bIns="0">
+          <a:bodyPr wrap="square" anchor="ctr" lIns="0" rIns="0" tIns="0" bIns="0">
             <a:spAutoFit/>
           </a:bodyPr>
           <a:lstStyle/>
@@ -11583,13 +12059,22 @@
               </a:lnSpc>
             </a:pPr>
             <a:r>
-              <a:rPr sz="4000" b="1" i="0">
+              <a:rPr sz="2400" b="1" i="0">
                 <a:solidFill>
                   <a:srgbClr val="E7AC51"/>
                 </a:solidFill>
                 <a:latin typeface="Arial"/>
               </a:rPr>
               <a:t>82.2%</a:t>
+            </a:r>
+            <a:r>
+              <a:rPr sz="1300" b="0" i="0">
+                <a:solidFill>
+                  <a:srgbClr val="9DA9B5"/>
+                </a:solidFill>
+                <a:latin typeface="Arial"/>
+              </a:rPr>
+              <a:t>   Overall sensitivity</a:t>
             </a:r>
           </a:p>
         </p:txBody>
@@ -11602,8 +12087,8 @@
         </p:nvSpPr>
         <p:spPr>
           <a:xfrm>
-            <a:off x="777240" y="4206240"/>
-            <a:ext cx="2651760" cy="548640"/>
+            <a:off x="777240" y="4361688"/>
+            <a:ext cx="5852160" cy="457200"/>
           </a:xfrm>
           <a:prstGeom prst="rect">
             <a:avLst/>
@@ -11611,46 +12096,7 @@
           <a:noFill/>
         </p:spPr>
         <p:txBody>
-          <a:bodyPr wrap="square" anchor="t" lIns="0" rIns="0" tIns="0" bIns="0">
-            <a:spAutoFit/>
-          </a:bodyPr>
-          <a:lstStyle/>
-          <a:p>
-            <a:pPr algn="l">
-              <a:lnSpc>
-                <a:spcPct val="120000"/>
-              </a:lnSpc>
-            </a:pPr>
-            <a:r>
-              <a:rPr sz="1150" b="0" i="0">
-                <a:solidFill>
-                  <a:srgbClr val="9DA9B5"/>
-                </a:solidFill>
-                <a:latin typeface="Consolas"/>
-              </a:rPr>
-              <a:t>Overall sensitivity</a:t>
-            </a:r>
-          </a:p>
-        </p:txBody>
-      </p:sp>
-      <p:sp>
-        <p:nvSpPr>
-          <p:cNvPr id="9" name="TextBox 8"/>
-          <p:cNvSpPr txBox="1"/>
-          <p:nvPr/>
-        </p:nvSpPr>
-        <p:spPr>
-          <a:xfrm>
-            <a:off x="3520440" y="3383280"/>
-            <a:ext cx="2651760" cy="640080"/>
-          </a:xfrm>
-          <a:prstGeom prst="rect">
-            <a:avLst/>
-          </a:prstGeom>
-          <a:noFill/>
-        </p:spPr>
-        <p:txBody>
-          <a:bodyPr wrap="square" anchor="t" lIns="0" rIns="0" tIns="0" bIns="0">
+          <a:bodyPr wrap="square" anchor="ctr" lIns="0" rIns="0" tIns="0" bIns="0">
             <a:spAutoFit/>
           </a:bodyPr>
           <a:lstStyle/>
@@ -11661,7 +12107,7 @@
               </a:lnSpc>
             </a:pPr>
             <a:r>
-              <a:rPr sz="4000" b="1" i="0">
+              <a:rPr sz="2400" b="1" i="0">
                 <a:solidFill>
                   <a:srgbClr val="D9785B"/>
                 </a:solidFill>
@@ -11669,19 +12115,28 @@
               </a:rPr>
               <a:t>45.5%</a:t>
             </a:r>
-          </a:p>
-        </p:txBody>
-      </p:sp>
-      <p:sp>
-        <p:nvSpPr>
-          <p:cNvPr id="10" name="TextBox 9"/>
+            <a:r>
+              <a:rPr sz="1300" b="0" i="0">
+                <a:solidFill>
+                  <a:srgbClr val="9DA9B5"/>
+                </a:solidFill>
+                <a:latin typeface="Arial"/>
+              </a:rPr>
+              <a:t>   Subacute bleeds</a:t>
+            </a:r>
+          </a:p>
+        </p:txBody>
+      </p:sp>
+      <p:sp>
+        <p:nvSpPr>
+          <p:cNvPr id="9" name="TextBox 8"/>
           <p:cNvSpPr txBox="1"/>
           <p:nvPr/>
         </p:nvSpPr>
         <p:spPr>
           <a:xfrm>
-            <a:off x="3520440" y="4206240"/>
-            <a:ext cx="2651760" cy="548640"/>
+            <a:off x="777240" y="4928616"/>
+            <a:ext cx="5852160" cy="457200"/>
           </a:xfrm>
           <a:prstGeom prst="rect">
             <a:avLst/>
@@ -11689,46 +12144,7 @@
           <a:noFill/>
         </p:spPr>
         <p:txBody>
-          <a:bodyPr wrap="square" anchor="t" lIns="0" rIns="0" tIns="0" bIns="0">
-            <a:spAutoFit/>
-          </a:bodyPr>
-          <a:lstStyle/>
-          <a:p>
-            <a:pPr algn="l">
-              <a:lnSpc>
-                <a:spcPct val="120000"/>
-              </a:lnSpc>
-            </a:pPr>
-            <a:r>
-              <a:rPr sz="1150" b="0" i="0">
-                <a:solidFill>
-                  <a:srgbClr val="9DA9B5"/>
-                </a:solidFill>
-                <a:latin typeface="Consolas"/>
-              </a:rPr>
-              <a:t>Subacute bleeds</a:t>
-            </a:r>
-          </a:p>
-        </p:txBody>
-      </p:sp>
-      <p:sp>
-        <p:nvSpPr>
-          <p:cNvPr id="11" name="TextBox 10"/>
-          <p:cNvSpPr txBox="1"/>
-          <p:nvPr/>
-        </p:nvSpPr>
-        <p:spPr>
-          <a:xfrm>
-            <a:off x="6263640" y="3383280"/>
-            <a:ext cx="2651760" cy="640080"/>
-          </a:xfrm>
-          <a:prstGeom prst="rect">
-            <a:avLst/>
-          </a:prstGeom>
-          <a:noFill/>
-        </p:spPr>
-        <p:txBody>
-          <a:bodyPr wrap="square" anchor="t" lIns="0" rIns="0" tIns="0" bIns="0">
+          <a:bodyPr wrap="square" anchor="ctr" lIns="0" rIns="0" tIns="0" bIns="0">
             <a:spAutoFit/>
           </a:bodyPr>
           <a:lstStyle/>
@@ -11739,7 +12155,7 @@
               </a:lnSpc>
             </a:pPr>
             <a:r>
-              <a:rPr sz="4000" b="1" i="0">
+              <a:rPr sz="2400" b="1" i="0">
                 <a:solidFill>
                   <a:srgbClr val="D9785B"/>
                 </a:solidFill>
@@ -11747,19 +12163,28 @@
               </a:rPr>
               <a:t>54.8%</a:t>
             </a:r>
-          </a:p>
-        </p:txBody>
-      </p:sp>
-      <p:sp>
-        <p:nvSpPr>
-          <p:cNvPr id="12" name="TextBox 11"/>
+            <a:r>
+              <a:rPr sz="1300" b="0" i="0">
+                <a:solidFill>
+                  <a:srgbClr val="9DA9B5"/>
+                </a:solidFill>
+                <a:latin typeface="Arial"/>
+              </a:rPr>
+              <a:t>   Chronic bleeds</a:t>
+            </a:r>
+          </a:p>
+        </p:txBody>
+      </p:sp>
+      <p:sp>
+        <p:nvSpPr>
+          <p:cNvPr id="10" name="TextBox 9"/>
           <p:cNvSpPr txBox="1"/>
           <p:nvPr/>
         </p:nvSpPr>
         <p:spPr>
           <a:xfrm>
-            <a:off x="6263640" y="4206240"/>
-            <a:ext cx="2651760" cy="548640"/>
+            <a:off x="777240" y="5495544"/>
+            <a:ext cx="5852160" cy="457200"/>
           </a:xfrm>
           <a:prstGeom prst="rect">
             <a:avLst/>
@@ -11767,46 +12192,7 @@
           <a:noFill/>
         </p:spPr>
         <p:txBody>
-          <a:bodyPr wrap="square" anchor="t" lIns="0" rIns="0" tIns="0" bIns="0">
-            <a:spAutoFit/>
-          </a:bodyPr>
-          <a:lstStyle/>
-          <a:p>
-            <a:pPr algn="l">
-              <a:lnSpc>
-                <a:spcPct val="120000"/>
-              </a:lnSpc>
-            </a:pPr>
-            <a:r>
-              <a:rPr sz="1150" b="0" i="0">
-                <a:solidFill>
-                  <a:srgbClr val="9DA9B5"/>
-                </a:solidFill>
-                <a:latin typeface="Consolas"/>
-              </a:rPr>
-              <a:t>Chronic bleeds</a:t>
-            </a:r>
-          </a:p>
-        </p:txBody>
-      </p:sp>
-      <p:sp>
-        <p:nvSpPr>
-          <p:cNvPr id="13" name="TextBox 12"/>
-          <p:cNvSpPr txBox="1"/>
-          <p:nvPr/>
-        </p:nvSpPr>
-        <p:spPr>
-          <a:xfrm>
-            <a:off x="9006840" y="3383280"/>
-            <a:ext cx="2651760" cy="640080"/>
-          </a:xfrm>
-          <a:prstGeom prst="rect">
-            <a:avLst/>
-          </a:prstGeom>
-          <a:noFill/>
-        </p:spPr>
-        <p:txBody>
-          <a:bodyPr wrap="square" anchor="t" lIns="0" rIns="0" tIns="0" bIns="0">
+          <a:bodyPr wrap="square" anchor="ctr" lIns="0" rIns="0" tIns="0" bIns="0">
             <a:spAutoFit/>
           </a:bodyPr>
           <a:lstStyle/>
@@ -11817,66 +12203,36 @@
               </a:lnSpc>
             </a:pPr>
             <a:r>
-              <a:rPr sz="4000" b="1" i="0">
-                <a:solidFill>
-                  <a:srgbClr val="E7AC51"/>
+              <a:rPr sz="2400" b="1" i="0">
+                <a:solidFill>
+                  <a:srgbClr val="5FB7C9"/>
                 </a:solidFill>
                 <a:latin typeface="Arial"/>
               </a:rPr>
               <a:t>72.2%</a:t>
             </a:r>
-          </a:p>
-        </p:txBody>
-      </p:sp>
-      <p:sp>
-        <p:nvSpPr>
-          <p:cNvPr id="14" name="TextBox 13"/>
+            <a:r>
+              <a:rPr sz="1300" b="0" i="0">
+                <a:solidFill>
+                  <a:srgbClr val="9DA9B5"/>
+                </a:solidFill>
+                <a:latin typeface="Arial"/>
+              </a:rPr>
+              <a:t>   Outpatient setting</a:t>
+            </a:r>
+          </a:p>
+        </p:txBody>
+      </p:sp>
+      <p:sp>
+        <p:nvSpPr>
+          <p:cNvPr id="11" name="TextBox 10"/>
           <p:cNvSpPr txBox="1"/>
           <p:nvPr/>
         </p:nvSpPr>
         <p:spPr>
           <a:xfrm>
-            <a:off x="9006840" y="4206240"/>
-            <a:ext cx="2651760" cy="548640"/>
-          </a:xfrm>
-          <a:prstGeom prst="rect">
-            <a:avLst/>
-          </a:prstGeom>
-          <a:noFill/>
-        </p:spPr>
-        <p:txBody>
-          <a:bodyPr wrap="square" anchor="t" lIns="0" rIns="0" tIns="0" bIns="0">
-            <a:spAutoFit/>
-          </a:bodyPr>
-          <a:lstStyle/>
-          <a:p>
-            <a:pPr algn="l">
-              <a:lnSpc>
-                <a:spcPct val="120000"/>
-              </a:lnSpc>
-            </a:pPr>
-            <a:r>
-              <a:rPr sz="1150" b="0" i="0">
-                <a:solidFill>
-                  <a:srgbClr val="9DA9B5"/>
-                </a:solidFill>
-                <a:latin typeface="Consolas"/>
-              </a:rPr>
-              <a:t>Outpatient setting</a:t>
-            </a:r>
-          </a:p>
-        </p:txBody>
-      </p:sp>
-      <p:sp>
-        <p:nvSpPr>
-          <p:cNvPr id="15" name="TextBox 14"/>
-          <p:cNvSpPr txBox="1"/>
-          <p:nvPr/>
-        </p:nvSpPr>
-        <p:spPr>
-          <a:xfrm>
-            <a:off x="777240" y="5394960"/>
-            <a:ext cx="10607040" cy="457200"/>
+            <a:off x="777240" y="6172200"/>
+            <a:ext cx="5486400" cy="457200"/>
           </a:xfrm>
           <a:prstGeom prst="rect">
             <a:avLst/>
@@ -11902,6 +12258,83 @@
                 <a:latin typeface="Consolas"/>
               </a:rPr>
               <a:t>[your group], npj Digital Medicine 2025.</a:t>
+            </a:r>
+          </a:p>
+        </p:txBody>
+      </p:sp>
+      <p:sp>
+        <p:nvSpPr>
+          <p:cNvPr id="12" name="Rounded Rectangle 11"/>
+          <p:cNvSpPr/>
+          <p:nvPr/>
+        </p:nvSpPr>
+        <p:spPr>
+          <a:xfrm>
+            <a:off x="6583680" y="1188720"/>
+            <a:ext cx="5120640" cy="4754880"/>
+          </a:xfrm>
+          <a:prstGeom prst="roundRect">
+            <a:avLst/>
+          </a:prstGeom>
+          <a:noFill/>
+          <a:ln w="12700">
+            <a:solidFill>
+              <a:srgbClr val="C98A2E"/>
+            </a:solidFill>
+            <a:prstDash val="dash"/>
+          </a:ln>
+          <a:effectLst/>
+        </p:spPr>
+        <p:style>
+          <a:lnRef idx="1">
+            <a:schemeClr val="accent1"/>
+          </a:lnRef>
+          <a:fillRef idx="3">
+            <a:schemeClr val="accent1"/>
+          </a:fillRef>
+          <a:effectRef idx="2">
+            <a:schemeClr val="accent1"/>
+          </a:effectRef>
+          <a:fontRef idx="minor">
+            <a:schemeClr val="lt1"/>
+          </a:fontRef>
+        </p:style>
+        <p:txBody>
+          <a:bodyPr rtlCol="0" anchor="ctr" wrap="square"/>
+          <a:lstStyle/>
+          <a:p>
+            <a:pPr algn="ctr">
+              <a:lnSpc>
+                <a:spcPct val="100000"/>
+              </a:lnSpc>
+            </a:pPr>
+            <a:r>
+              <a:rPr sz="1100" b="0" i="0">
+                <a:solidFill>
+                  <a:srgbClr val="E7AC51"/>
+                </a:solidFill>
+                <a:latin typeface="Consolas"/>
+              </a:rPr>
+              <a:t>GIF</a:t>
+            </a:r>
+          </a:p>
+          <a:p>
+            <a:pPr algn="ctr">
+              <a:lnSpc>
+                <a:spcPct val="100000"/>
+              </a:lnSpc>
+              <a:spcBef>
+                <a:spcPts val="300"/>
+              </a:spcBef>
+            </a:pPr>
+            <a:r>
+              <a:rPr sz="900" b="0" i="0">
+                <a:solidFill>
+                  <a:srgbClr val="5C6975"/>
+                </a:solidFill>
+                <a:latin typeface="Consolas"/>
+              </a:rPr>
+              <a:t>[ to be added ]</a:t>
             </a:r>
           </a:p>
         </p:txBody>
@@ -12385,7 +12818,7 @@
         <p:spPr>
           <a:xfrm>
             <a:off x="777240" y="1005840"/>
-            <a:ext cx="10607040" cy="1280160"/>
+            <a:ext cx="5852160" cy="1280160"/>
           </a:xfrm>
           <a:prstGeom prst="rect">
             <a:avLst/>
@@ -12432,8 +12865,8 @@
         </p:nvSpPr>
         <p:spPr>
           <a:xfrm>
-            <a:off x="777240" y="2194560"/>
-            <a:ext cx="10058400" cy="640080"/>
+            <a:off x="777240" y="2103120"/>
+            <a:ext cx="5669280" cy="640080"/>
           </a:xfrm>
           <a:prstGeom prst="rect">
             <a:avLst/>
@@ -12469,28 +12902,58 @@
               </a:rPr>
               <a:t>AWS Open Data Program.</a:t>
             </a:r>
-            <a:r>
-              <a:rPr sz="1500" b="0" i="0">
-                <a:solidFill>
-                  <a:srgbClr val="9DA9B5"/>
-                </a:solidFill>
-                <a:latin typeface="Arial"/>
-              </a:rPr>
-              <a:t>  EMBED v2 is in progress.</a:t>
-            </a:r>
-          </a:p>
-        </p:txBody>
-      </p:sp>
-      <p:sp>
-        <p:nvSpPr>
-          <p:cNvPr id="7" name="Rounded Rectangle 6"/>
+          </a:p>
+        </p:txBody>
+      </p:sp>
+      <p:sp>
+        <p:nvSpPr>
+          <p:cNvPr id="7" name="TextBox 6"/>
+          <p:cNvSpPr txBox="1"/>
+          <p:nvPr/>
+        </p:nvSpPr>
+        <p:spPr>
+          <a:xfrm>
+            <a:off x="777240" y="2788920"/>
+            <a:ext cx="5852160" cy="320040"/>
+          </a:xfrm>
+          <a:prstGeom prst="rect">
+            <a:avLst/>
+          </a:prstGeom>
+          <a:noFill/>
+        </p:spPr>
+        <p:txBody>
+          <a:bodyPr wrap="square" anchor="t" lIns="0" rIns="0" tIns="0" bIns="0">
+            <a:spAutoFit/>
+          </a:bodyPr>
+          <a:lstStyle/>
+          <a:p>
+            <a:pPr algn="l">
+              <a:lnSpc>
+                <a:spcPct val="100000"/>
+              </a:lnSpc>
+            </a:pPr>
+            <a:r>
+              <a:rPr sz="1150" b="1" i="0">
+                <a:solidFill>
+                  <a:srgbClr val="E7AC51"/>
+                </a:solidFill>
+                <a:latin typeface="Consolas"/>
+              </a:rPr>
+              <a:t>EMBED V2 — IN PROGRESS</a:t>
+            </a:r>
+          </a:p>
+        </p:txBody>
+      </p:sp>
+      <p:sp>
+        <p:nvSpPr>
+          <p:cNvPr id="8" name="Rounded Rectangle 7"/>
           <p:cNvSpPr/>
           <p:nvPr/>
         </p:nvSpPr>
         <p:spPr>
           <a:xfrm>
-            <a:off x="777240" y="3200400"/>
-            <a:ext cx="1704441" cy="384048"/>
+            <a:off x="777240" y="3246120"/>
+            <a:ext cx="1722455" cy="384048"/>
           </a:xfrm>
           <a:prstGeom prst="roundRect">
             <a:avLst/>
@@ -12520,7 +12983,7 @@
           </a:fontRef>
         </p:style>
         <p:txBody>
-          <a:bodyPr rtlCol="0" anchor="ctr" wrap="square" lIns="128016"/>
+          <a:bodyPr rtlCol="0" anchor="ctr" wrap="none" lIns="137160" tIns="0" bIns="0"/>
           <a:lstStyle/>
           <a:p>
             <a:pPr algn="l">
@@ -12529,27 +12992,36 @@
               </a:lnSpc>
             </a:pPr>
             <a:r>
-              <a:rPr sz="1100" b="0" i="0">
+              <a:rPr sz="1050" b="0" i="0">
                 <a:solidFill>
                   <a:srgbClr val="ECEFF3"/>
                 </a:solidFill>
                 <a:latin typeface="Consolas"/>
               </a:rPr>
-              <a:t>~300,000 patients</a:t>
-            </a:r>
-          </a:p>
-        </p:txBody>
-      </p:sp>
-      <p:sp>
-        <p:nvSpPr>
-          <p:cNvPr id="8" name="Rectangle 7"/>
+              <a:t>~300,000 </a:t>
+            </a:r>
+            <a:r>
+              <a:rPr sz="1050" b="1" i="0">
+                <a:solidFill>
+                  <a:srgbClr val="5FB7C9"/>
+                </a:solidFill>
+                <a:latin typeface="Consolas"/>
+              </a:rPr>
+              <a:t>patients</a:t>
+            </a:r>
+          </a:p>
+        </p:txBody>
+      </p:sp>
+      <p:sp>
+        <p:nvSpPr>
+          <p:cNvPr id="9" name="Rectangle 8"/>
           <p:cNvSpPr/>
           <p:nvPr/>
         </p:nvSpPr>
         <p:spPr>
           <a:xfrm>
-            <a:off x="777240" y="3200400"/>
-            <a:ext cx="36576" cy="384048"/>
+            <a:off x="777240" y="3246120"/>
+            <a:ext cx="41148" cy="384048"/>
           </a:xfrm>
           <a:prstGeom prst="rect">
             <a:avLst/>
@@ -12586,14 +13058,14 @@
       </p:sp>
       <p:sp>
         <p:nvSpPr>
-          <p:cNvPr id="9" name="Rounded Rectangle 8"/>
+          <p:cNvPr id="10" name="Rounded Rectangle 9"/>
           <p:cNvSpPr/>
           <p:nvPr/>
         </p:nvSpPr>
         <p:spPr>
           <a:xfrm>
-            <a:off x="2618841" y="3200400"/>
-            <a:ext cx="2882188" cy="384048"/>
+            <a:off x="2645999" y="3246120"/>
+            <a:ext cx="2824673" cy="384048"/>
           </a:xfrm>
           <a:prstGeom prst="roundRect">
             <a:avLst/>
@@ -12623,7 +13095,7 @@
           </a:fontRef>
         </p:style>
         <p:txBody>
-          <a:bodyPr rtlCol="0" anchor="ctr" wrap="square" lIns="128016"/>
+          <a:bodyPr rtlCol="0" anchor="ctr" wrap="none" lIns="137160" tIns="0" bIns="0"/>
           <a:lstStyle/>
           <a:p>
             <a:pPr algn="l">
@@ -12632,27 +13104,45 @@
               </a:lnSpc>
             </a:pPr>
             <a:r>
-              <a:rPr sz="1100" b="0" i="0">
+              <a:rPr sz="1050" b="0" i="0">
                 <a:solidFill>
                   <a:srgbClr val="ECEFF3"/>
                 </a:solidFill>
                 <a:latin typeface="Consolas"/>
               </a:rPr>
-              <a:t>~1M exams (2D · DBT · US · MRI)</a:t>
-            </a:r>
-          </a:p>
-        </p:txBody>
-      </p:sp>
-      <p:sp>
-        <p:nvSpPr>
-          <p:cNvPr id="10" name="Rectangle 9"/>
+              <a:t>~1M </a:t>
+            </a:r>
+            <a:r>
+              <a:rPr sz="1050" b="1" i="0">
+                <a:solidFill>
+                  <a:srgbClr val="5FB7C9"/>
+                </a:solidFill>
+                <a:latin typeface="Consolas"/>
+              </a:rPr>
+              <a:t>exams</a:t>
+            </a:r>
+            <a:r>
+              <a:rPr sz="1050" b="0" i="0">
+                <a:solidFill>
+                  <a:srgbClr val="ECEFF3"/>
+                </a:solidFill>
+                <a:latin typeface="Consolas"/>
+              </a:rPr>
+              <a:t> (2D · DBT · US · MRI)</a:t>
+            </a:r>
+          </a:p>
+        </p:txBody>
+      </p:sp>
+      <p:sp>
+        <p:nvSpPr>
+          <p:cNvPr id="11" name="Rectangle 10"/>
           <p:cNvSpPr/>
           <p:nvPr/>
         </p:nvSpPr>
         <p:spPr>
           <a:xfrm>
-            <a:off x="2618841" y="3200400"/>
-            <a:ext cx="36576" cy="384048"/>
+            <a:off x="2645999" y="3246120"/>
+            <a:ext cx="41148" cy="384048"/>
           </a:xfrm>
           <a:prstGeom prst="rect">
             <a:avLst/>
@@ -12689,14 +13179,14 @@
       </p:sp>
       <p:sp>
         <p:nvSpPr>
-          <p:cNvPr id="11" name="Rounded Rectangle 10"/>
+          <p:cNvPr id="12" name="Rounded Rectangle 11"/>
           <p:cNvSpPr/>
           <p:nvPr/>
         </p:nvSpPr>
         <p:spPr>
           <a:xfrm>
-            <a:off x="5638190" y="3200400"/>
-            <a:ext cx="1704441" cy="384048"/>
+            <a:off x="777240" y="3749039"/>
+            <a:ext cx="1722455" cy="384048"/>
           </a:xfrm>
           <a:prstGeom prst="roundRect">
             <a:avLst/>
@@ -12726,7 +13216,7 @@
           </a:fontRef>
         </p:style>
         <p:txBody>
-          <a:bodyPr rtlCol="0" anchor="ctr" wrap="square" lIns="128016"/>
+          <a:bodyPr rtlCol="0" anchor="ctr" wrap="none" lIns="137160" tIns="0" bIns="0"/>
           <a:lstStyle/>
           <a:p>
             <a:pPr algn="l">
@@ -12735,27 +13225,36 @@
               </a:lnSpc>
             </a:pPr>
             <a:r>
-              <a:rPr sz="1100" b="0" i="0">
+              <a:rPr sz="1050" b="0" i="0">
                 <a:solidFill>
                   <a:srgbClr val="ECEFF3"/>
                 </a:solidFill>
                 <a:latin typeface="Consolas"/>
               </a:rPr>
-              <a:t>Free-text reports</a:t>
-            </a:r>
-          </a:p>
-        </p:txBody>
-      </p:sp>
-      <p:sp>
-        <p:nvSpPr>
-          <p:cNvPr id="12" name="Rectangle 11"/>
+              <a:t>Free-text </a:t>
+            </a:r>
+            <a:r>
+              <a:rPr sz="1050" b="1" i="0">
+                <a:solidFill>
+                  <a:srgbClr val="5FB7C9"/>
+                </a:solidFill>
+                <a:latin typeface="Consolas"/>
+              </a:rPr>
+              <a:t>reports</a:t>
+            </a:r>
+          </a:p>
+        </p:txBody>
+      </p:sp>
+      <p:sp>
+        <p:nvSpPr>
+          <p:cNvPr id="13" name="Rectangle 12"/>
           <p:cNvSpPr/>
           <p:nvPr/>
         </p:nvSpPr>
         <p:spPr>
           <a:xfrm>
-            <a:off x="5638190" y="3200400"/>
-            <a:ext cx="36576" cy="384048"/>
+            <a:off x="777240" y="3749039"/>
+            <a:ext cx="41148" cy="384048"/>
           </a:xfrm>
           <a:prstGeom prst="rect">
             <a:avLst/>
@@ -12792,14 +13291,14 @@
       </p:sp>
       <p:sp>
         <p:nvSpPr>
-          <p:cNvPr id="13" name="Rounded Rectangle 12"/>
+          <p:cNvPr id="14" name="Rounded Rectangle 13"/>
           <p:cNvSpPr/>
           <p:nvPr/>
         </p:nvSpPr>
         <p:spPr>
           <a:xfrm>
-            <a:off x="7479792" y="3200400"/>
-            <a:ext cx="1704441" cy="384048"/>
+            <a:off x="2645999" y="3749039"/>
+            <a:ext cx="1722455" cy="384048"/>
           </a:xfrm>
           <a:prstGeom prst="roundRect">
             <a:avLst/>
@@ -12829,7 +13328,7 @@
           </a:fontRef>
         </p:style>
         <p:txBody>
-          <a:bodyPr rtlCol="0" anchor="ctr" wrap="square" lIns="128016"/>
+          <a:bodyPr rtlCol="0" anchor="ctr" wrap="none" lIns="137160" tIns="0" bIns="0"/>
           <a:lstStyle/>
           <a:p>
             <a:pPr algn="l">
@@ -12838,27 +13337,36 @@
               </a:lnSpc>
             </a:pPr>
             <a:r>
-              <a:rPr sz="1100" b="0" i="0">
+              <a:rPr sz="1050" b="0" i="0">
                 <a:solidFill>
                   <a:srgbClr val="ECEFF3"/>
                 </a:solidFill>
                 <a:latin typeface="Consolas"/>
               </a:rPr>
-              <a:t>Patient risk data</a:t>
-            </a:r>
-          </a:p>
-        </p:txBody>
-      </p:sp>
-      <p:sp>
-        <p:nvSpPr>
-          <p:cNvPr id="14" name="Rectangle 13"/>
+              <a:t>Patient </a:t>
+            </a:r>
+            <a:r>
+              <a:rPr sz="1050" b="1" i="0">
+                <a:solidFill>
+                  <a:srgbClr val="5FB7C9"/>
+                </a:solidFill>
+                <a:latin typeface="Consolas"/>
+              </a:rPr>
+              <a:t>risk data</a:t>
+            </a:r>
+          </a:p>
+        </p:txBody>
+      </p:sp>
+      <p:sp>
+        <p:nvSpPr>
+          <p:cNvPr id="15" name="Rectangle 14"/>
           <p:cNvSpPr/>
           <p:nvPr/>
         </p:nvSpPr>
         <p:spPr>
           <a:xfrm>
-            <a:off x="7479792" y="3200400"/>
-            <a:ext cx="36576" cy="384048"/>
+            <a:off x="2645999" y="3749039"/>
+            <a:ext cx="41148" cy="384048"/>
           </a:xfrm>
           <a:prstGeom prst="rect">
             <a:avLst/>
@@ -12895,14 +13403,14 @@
       </p:sp>
       <p:sp>
         <p:nvSpPr>
-          <p:cNvPr id="15" name="Rounded Rectangle 14"/>
+          <p:cNvPr id="16" name="Rounded Rectangle 15"/>
           <p:cNvSpPr/>
           <p:nvPr/>
         </p:nvSpPr>
         <p:spPr>
           <a:xfrm>
-            <a:off x="777240" y="3703320"/>
-            <a:ext cx="2629814" cy="384048"/>
+            <a:off x="777240" y="4251959"/>
+            <a:ext cx="2588483" cy="384048"/>
           </a:xfrm>
           <a:prstGeom prst="roundRect">
             <a:avLst/>
@@ -12932,7 +13440,7 @@
           </a:fontRef>
         </p:style>
         <p:txBody>
-          <a:bodyPr rtlCol="0" anchor="ctr" wrap="square" lIns="128016"/>
+          <a:bodyPr rtlCol="0" anchor="ctr" wrap="none" lIns="137160" tIns="0" bIns="0"/>
           <a:lstStyle/>
           <a:p>
             <a:pPr algn="l">
@@ -12941,27 +13449,36 @@
               </a:lnSpc>
             </a:pPr>
             <a:r>
-              <a:rPr sz="1100" b="0" i="0">
+              <a:rPr sz="1050" b="0" i="0">
                 <a:solidFill>
                   <a:srgbClr val="ECEFF3"/>
                 </a:solidFill>
                 <a:latin typeface="Consolas"/>
               </a:rPr>
-              <a:t>Outcomes registry-harmonized</a:t>
-            </a:r>
-          </a:p>
-        </p:txBody>
-      </p:sp>
-      <p:sp>
-        <p:nvSpPr>
-          <p:cNvPr id="16" name="Rectangle 15"/>
+              <a:t>Outcomes </a:t>
+            </a:r>
+            <a:r>
+              <a:rPr sz="1050" b="1" i="0">
+                <a:solidFill>
+                  <a:srgbClr val="5FB7C9"/>
+                </a:solidFill>
+                <a:latin typeface="Consolas"/>
+              </a:rPr>
+              <a:t>registry-harmonized</a:t>
+            </a:r>
+          </a:p>
+        </p:txBody>
+      </p:sp>
+      <p:sp>
+        <p:nvSpPr>
+          <p:cNvPr id="17" name="Rectangle 16"/>
           <p:cNvSpPr/>
           <p:nvPr/>
         </p:nvSpPr>
         <p:spPr>
           <a:xfrm>
-            <a:off x="777240" y="3703320"/>
-            <a:ext cx="36576" cy="384048"/>
+            <a:off x="777240" y="4251959"/>
+            <a:ext cx="41148" cy="384048"/>
           </a:xfrm>
           <a:prstGeom prst="rect">
             <a:avLst/>
@@ -12998,14 +13515,14 @@
       </p:sp>
       <p:sp>
         <p:nvSpPr>
-          <p:cNvPr id="17" name="TextBox 16"/>
+          <p:cNvPr id="18" name="TextBox 17"/>
           <p:cNvSpPr txBox="1"/>
           <p:nvPr/>
         </p:nvSpPr>
         <p:spPr>
           <a:xfrm>
-            <a:off x="777240" y="5852160"/>
-            <a:ext cx="10607040" cy="457200"/>
+            <a:off x="777240" y="5897880"/>
+            <a:ext cx="5852160" cy="457200"/>
           </a:xfrm>
           <a:prstGeom prst="rect">
             <a:avLst/>
@@ -13031,6 +13548,122 @@
                 <a:latin typeface="Consolas"/>
               </a:rPr>
               <a:t>v1: [your group], Radiology: Artificial Intelligence 2023 (Fig. 1) · aws.amazon.com/opendata</a:t>
+            </a:r>
+          </a:p>
+        </p:txBody>
+      </p:sp>
+      <p:sp>
+        <p:nvSpPr>
+          <p:cNvPr id="19" name="Rounded Rectangle 18"/>
+          <p:cNvSpPr/>
+          <p:nvPr/>
+        </p:nvSpPr>
+        <p:spPr>
+          <a:xfrm>
+            <a:off x="6583680" y="1188720"/>
+            <a:ext cx="5120640" cy="4480560"/>
+          </a:xfrm>
+          <a:prstGeom prst="roundRect">
+            <a:avLst/>
+          </a:prstGeom>
+          <a:noFill/>
+          <a:ln w="12700">
+            <a:solidFill>
+              <a:srgbClr val="C98A2E"/>
+            </a:solidFill>
+            <a:prstDash val="dash"/>
+          </a:ln>
+          <a:effectLst/>
+        </p:spPr>
+        <p:style>
+          <a:lnRef idx="1">
+            <a:schemeClr val="accent1"/>
+          </a:lnRef>
+          <a:fillRef idx="3">
+            <a:schemeClr val="accent1"/>
+          </a:fillRef>
+          <a:effectRef idx="2">
+            <a:schemeClr val="accent1"/>
+          </a:effectRef>
+          <a:fontRef idx="minor">
+            <a:schemeClr val="lt1"/>
+          </a:fontRef>
+        </p:style>
+        <p:txBody>
+          <a:bodyPr rtlCol="0" anchor="ctr" wrap="square"/>
+          <a:lstStyle/>
+          <a:p>
+            <a:pPr algn="ctr">
+              <a:lnSpc>
+                <a:spcPct val="100000"/>
+              </a:lnSpc>
+            </a:pPr>
+            <a:r>
+              <a:rPr sz="1100" b="0" i="0">
+                <a:solidFill>
+                  <a:srgbClr val="E7AC51"/>
+                </a:solidFill>
+                <a:latin typeface="Consolas"/>
+              </a:rPr>
+              <a:t>MAP — EMBED USERS BY COUNTRY</a:t>
+            </a:r>
+          </a:p>
+          <a:p>
+            <a:pPr algn="ctr">
+              <a:lnSpc>
+                <a:spcPct val="100000"/>
+              </a:lnSpc>
+              <a:spcBef>
+                <a:spcPts val="300"/>
+              </a:spcBef>
+            </a:pPr>
+            <a:r>
+              <a:rPr sz="900" b="0" i="0">
+                <a:solidFill>
+                  <a:srgbClr val="5C6975"/>
+                </a:solidFill>
+                <a:latin typeface="Consolas"/>
+              </a:rPr>
+              <a:t>[ drop in PNG ]</a:t>
+            </a:r>
+          </a:p>
+        </p:txBody>
+      </p:sp>
+      <p:sp>
+        <p:nvSpPr>
+          <p:cNvPr id="20" name="TextBox 19"/>
+          <p:cNvSpPr txBox="1"/>
+          <p:nvPr/>
+        </p:nvSpPr>
+        <p:spPr>
+          <a:xfrm>
+            <a:off x="6583680" y="5760720"/>
+            <a:ext cx="5120640" cy="274320"/>
+          </a:xfrm>
+          <a:prstGeom prst="rect">
+            <a:avLst/>
+          </a:prstGeom>
+          <a:noFill/>
+        </p:spPr>
+        <p:txBody>
+          <a:bodyPr wrap="square" anchor="t" lIns="0" rIns="0" tIns="0" bIns="0">
+            <a:spAutoFit/>
+          </a:bodyPr>
+          <a:lstStyle/>
+          <a:p>
+            <a:pPr algn="ctr">
+              <a:lnSpc>
+                <a:spcPct val="100000"/>
+              </a:lnSpc>
+            </a:pPr>
+            <a:r>
+              <a:rPr sz="900" b="0" i="0">
+                <a:solidFill>
+                  <a:srgbClr val="5C6975"/>
+                </a:solidFill>
+                <a:latin typeface="Consolas"/>
+              </a:rPr>
+              <a:t>opt: EMBED v1 schematic — Radiology: AI, Fig. 1</a:t>
             </a:r>
           </a:p>
         </p:txBody>

</xml_diff>